<commit_message>
docs: update lab validation test output for missing files
</commit_message>
<xml_diff>
--- a/delivery-resources/ILL335-Attendee-Walkthrough-FY27.pptx
+++ b/delivery-resources/ILL335-Attendee-Walkthrough-FY27.pptx
@@ -136,1228 +136,6 @@
 </p:presentation>
 </file>
 
-<file path=ppt/revisionInfo.xml><?xml version="1.0" encoding="utf-8"?>
-<p1510:revInfo xmlns:a="http://schemas.openxmlformats.org/drawingml/2006/main" xmlns:r="http://schemas.openxmlformats.org/officeDocument/2006/relationships" xmlns:p1510="http://schemas.microsoft.com/office/powerpoint/2015/10/main">
-  <p1510:revLst>
-    <p1510:client id="{3B616A61-3D63-42A9-9A15-B66DB0152D2D}" v="3" dt="2026-08-31T18:56:04.269"/>
-    <p1510:client id="{96ED3947-707C-4D70-8CA7-68F33CA57B66}" v="36" dt="2026-09-01T15:18:20.202"/>
-  </p1510:revLst>
-</p1510:revInfo>
-</file>
-
-<file path=ppt/changesInfos/changesInfo1.xml><?xml version="1.0" encoding="utf-8"?>
-<pc:chgInfo xmlns:a="http://schemas.openxmlformats.org/drawingml/2006/main" xmlns:r="http://schemas.openxmlformats.org/officeDocument/2006/relationships" xmlns:ac="http://schemas.microsoft.com/office/drawing/2013/main/command" xmlns:pc="http://schemas.microsoft.com/office/powerpoint/2013/main/command">
-  <pc:docChgLst>
-    <pc:chgData name="Clover Sin I Chang (Stinson Communications Inc)" userId="73b31ea9-7b99-4cbb-9f95-6d9e36522bc0" providerId="ADAL" clId="{9ACEEF60-B8C4-4D3A-B0A8-7FADAC6D59DB}"/>
-    <pc:docChg chg="undo custSel addSld delSld modSld delMainMaster">
-      <pc:chgData name="Clover Sin I Chang (Stinson Communications Inc)" userId="73b31ea9-7b99-4cbb-9f95-6d9e36522bc0" providerId="ADAL" clId="{9ACEEF60-B8C4-4D3A-B0A8-7FADAC6D59DB}" dt="2026-09-01T15:18:20.202" v="293" actId="20577"/>
-      <pc:docMkLst>
-        <pc:docMk/>
-      </pc:docMkLst>
-      <pc:sldChg chg="del">
-        <pc:chgData name="Clover Sin I Chang (Stinson Communications Inc)" userId="73b31ea9-7b99-4cbb-9f95-6d9e36522bc0" providerId="ADAL" clId="{9ACEEF60-B8C4-4D3A-B0A8-7FADAC6D59DB}" dt="2026-09-01T15:04:45.253" v="16" actId="47"/>
-        <pc:sldMkLst>
-          <pc:docMk/>
-          <pc:sldMk cId="0" sldId="257"/>
-        </pc:sldMkLst>
-      </pc:sldChg>
-      <pc:sldChg chg="del">
-        <pc:chgData name="Clover Sin I Chang (Stinson Communications Inc)" userId="73b31ea9-7b99-4cbb-9f95-6d9e36522bc0" providerId="ADAL" clId="{9ACEEF60-B8C4-4D3A-B0A8-7FADAC6D59DB}" dt="2026-09-01T15:05:00.352" v="20" actId="47"/>
-        <pc:sldMkLst>
-          <pc:docMk/>
-          <pc:sldMk cId="0" sldId="258"/>
-        </pc:sldMkLst>
-      </pc:sldChg>
-      <pc:sldChg chg="del">
-        <pc:chgData name="Clover Sin I Chang (Stinson Communications Inc)" userId="73b31ea9-7b99-4cbb-9f95-6d9e36522bc0" providerId="ADAL" clId="{9ACEEF60-B8C4-4D3A-B0A8-7FADAC6D59DB}" dt="2026-09-01T15:05:19.971" v="25" actId="47"/>
-        <pc:sldMkLst>
-          <pc:docMk/>
-          <pc:sldMk cId="0" sldId="259"/>
-        </pc:sldMkLst>
-      </pc:sldChg>
-      <pc:sldChg chg="del">
-        <pc:chgData name="Clover Sin I Chang (Stinson Communications Inc)" userId="73b31ea9-7b99-4cbb-9f95-6d9e36522bc0" providerId="ADAL" clId="{9ACEEF60-B8C4-4D3A-B0A8-7FADAC6D59DB}" dt="2026-09-01T15:05:36.429" v="27" actId="47"/>
-        <pc:sldMkLst>
-          <pc:docMk/>
-          <pc:sldMk cId="0" sldId="260"/>
-        </pc:sldMkLst>
-      </pc:sldChg>
-      <pc:sldChg chg="del">
-        <pc:chgData name="Clover Sin I Chang (Stinson Communications Inc)" userId="73b31ea9-7b99-4cbb-9f95-6d9e36522bc0" providerId="ADAL" clId="{9ACEEF60-B8C4-4D3A-B0A8-7FADAC6D59DB}" dt="2026-09-01T15:05:49.072" v="29" actId="47"/>
-        <pc:sldMkLst>
-          <pc:docMk/>
-          <pc:sldMk cId="0" sldId="261"/>
-        </pc:sldMkLst>
-      </pc:sldChg>
-      <pc:sldChg chg="del">
-        <pc:chgData name="Clover Sin I Chang (Stinson Communications Inc)" userId="73b31ea9-7b99-4cbb-9f95-6d9e36522bc0" providerId="ADAL" clId="{9ACEEF60-B8C4-4D3A-B0A8-7FADAC6D59DB}" dt="2026-09-01T15:06:02.559" v="31" actId="47"/>
-        <pc:sldMkLst>
-          <pc:docMk/>
-          <pc:sldMk cId="0" sldId="262"/>
-        </pc:sldMkLst>
-      </pc:sldChg>
-      <pc:sldChg chg="del">
-        <pc:chgData name="Clover Sin I Chang (Stinson Communications Inc)" userId="73b31ea9-7b99-4cbb-9f95-6d9e36522bc0" providerId="ADAL" clId="{9ACEEF60-B8C4-4D3A-B0A8-7FADAC6D59DB}" dt="2026-09-01T15:06:17.474" v="33" actId="47"/>
-        <pc:sldMkLst>
-          <pc:docMk/>
-          <pc:sldMk cId="0" sldId="263"/>
-        </pc:sldMkLst>
-      </pc:sldChg>
-      <pc:sldChg chg="del">
-        <pc:chgData name="Clover Sin I Chang (Stinson Communications Inc)" userId="73b31ea9-7b99-4cbb-9f95-6d9e36522bc0" providerId="ADAL" clId="{9ACEEF60-B8C4-4D3A-B0A8-7FADAC6D59DB}" dt="2026-09-01T15:06:29.431" v="35" actId="47"/>
-        <pc:sldMkLst>
-          <pc:docMk/>
-          <pc:sldMk cId="0" sldId="264"/>
-        </pc:sldMkLst>
-      </pc:sldChg>
-      <pc:sldChg chg="del">
-        <pc:chgData name="Clover Sin I Chang (Stinson Communications Inc)" userId="73b31ea9-7b99-4cbb-9f95-6d9e36522bc0" providerId="ADAL" clId="{9ACEEF60-B8C4-4D3A-B0A8-7FADAC6D59DB}" dt="2026-09-01T15:06:36.742" v="37" actId="47"/>
-        <pc:sldMkLst>
-          <pc:docMk/>
-          <pc:sldMk cId="4061082036" sldId="2147479528"/>
-        </pc:sldMkLst>
-      </pc:sldChg>
-      <pc:sldChg chg="del">
-        <pc:chgData name="Clover Sin I Chang (Stinson Communications Inc)" userId="73b31ea9-7b99-4cbb-9f95-6d9e36522bc0" providerId="ADAL" clId="{9ACEEF60-B8C4-4D3A-B0A8-7FADAC6D59DB}" dt="2026-09-01T15:04:15.862" v="5" actId="47"/>
-        <pc:sldMkLst>
-          <pc:docMk/>
-          <pc:sldMk cId="1080857811" sldId="2147479540"/>
-        </pc:sldMkLst>
-      </pc:sldChg>
-      <pc:sldChg chg="del">
-        <pc:chgData name="Clover Sin I Chang (Stinson Communications Inc)" userId="73b31ea9-7b99-4cbb-9f95-6d9e36522bc0" providerId="ADAL" clId="{9ACEEF60-B8C4-4D3A-B0A8-7FADAC6D59DB}" dt="2026-09-01T15:04:22.642" v="9" actId="47"/>
-        <pc:sldMkLst>
-          <pc:docMk/>
-          <pc:sldMk cId="143569297" sldId="2147479558"/>
-        </pc:sldMkLst>
-      </pc:sldChg>
-      <pc:sldChg chg="modSp add del mod">
-        <pc:chgData name="Clover Sin I Chang (Stinson Communications Inc)" userId="73b31ea9-7b99-4cbb-9f95-6d9e36522bc0" providerId="ADAL" clId="{9ACEEF60-B8C4-4D3A-B0A8-7FADAC6D59DB}" dt="2026-09-01T15:04:14.093" v="3"/>
-        <pc:sldMkLst>
-          <pc:docMk/>
-          <pc:sldMk cId="16900448" sldId="2147479559"/>
-        </pc:sldMkLst>
-        <pc:spChg chg="mod">
-          <ac:chgData name="Clover Sin I Chang (Stinson Communications Inc)" userId="73b31ea9-7b99-4cbb-9f95-6d9e36522bc0" providerId="ADAL" clId="{9ACEEF60-B8C4-4D3A-B0A8-7FADAC6D59DB}" dt="2026-09-01T15:04:14.093" v="3"/>
-          <ac:spMkLst>
-            <pc:docMk/>
-            <pc:sldMk cId="16900448" sldId="2147479559"/>
-            <ac:spMk id="4" creationId="{5BCE0119-F82F-75EF-0AAE-422A9B463402}"/>
-          </ac:spMkLst>
-        </pc:spChg>
-      </pc:sldChg>
-      <pc:sldChg chg="add">
-        <pc:chgData name="Clover Sin I Chang (Stinson Communications Inc)" userId="73b31ea9-7b99-4cbb-9f95-6d9e36522bc0" providerId="ADAL" clId="{9ACEEF60-B8C4-4D3A-B0A8-7FADAC6D59DB}" dt="2026-09-01T15:04:14.122" v="4"/>
-        <pc:sldMkLst>
-          <pc:docMk/>
-          <pc:sldMk cId="425135901" sldId="2147479559"/>
-        </pc:sldMkLst>
-      </pc:sldChg>
-      <pc:sldChg chg="add">
-        <pc:chgData name="Clover Sin I Chang (Stinson Communications Inc)" userId="73b31ea9-7b99-4cbb-9f95-6d9e36522bc0" providerId="ADAL" clId="{9ACEEF60-B8C4-4D3A-B0A8-7FADAC6D59DB}" dt="2026-09-01T15:04:21.652" v="8"/>
-        <pc:sldMkLst>
-          <pc:docMk/>
-          <pc:sldMk cId="647699027" sldId="2147479560"/>
-        </pc:sldMkLst>
-      </pc:sldChg>
-      <pc:sldChg chg="add del">
-        <pc:chgData name="Clover Sin I Chang (Stinson Communications Inc)" userId="73b31ea9-7b99-4cbb-9f95-6d9e36522bc0" providerId="ADAL" clId="{9ACEEF60-B8C4-4D3A-B0A8-7FADAC6D59DB}" dt="2026-09-01T15:04:21.636" v="7"/>
-        <pc:sldMkLst>
-          <pc:docMk/>
-          <pc:sldMk cId="2193209997" sldId="2147479560"/>
-        </pc:sldMkLst>
-      </pc:sldChg>
-      <pc:sldChg chg="delSp modSp add del mod delAnim modAnim">
-        <pc:chgData name="Clover Sin I Chang (Stinson Communications Inc)" userId="73b31ea9-7b99-4cbb-9f95-6d9e36522bc0" providerId="ADAL" clId="{9ACEEF60-B8C4-4D3A-B0A8-7FADAC6D59DB}" dt="2026-09-01T15:11:35.310" v="198" actId="13244"/>
-        <pc:sldMkLst>
-          <pc:docMk/>
-          <pc:sldMk cId="1428960468" sldId="2147479561"/>
-        </pc:sldMkLst>
-        <pc:spChg chg="mod ord">
-          <ac:chgData name="Clover Sin I Chang (Stinson Communications Inc)" userId="73b31ea9-7b99-4cbb-9f95-6d9e36522bc0" providerId="ADAL" clId="{9ACEEF60-B8C4-4D3A-B0A8-7FADAC6D59DB}" dt="2026-09-01T15:11:12.779" v="191" actId="1035"/>
-          <ac:spMkLst>
-            <pc:docMk/>
-            <pc:sldMk cId="1428960468" sldId="2147479561"/>
-            <ac:spMk id="2" creationId="{C7824DFA-BE7D-BC3F-5069-3FD32CC3000D}"/>
-          </ac:spMkLst>
-        </pc:spChg>
-        <pc:spChg chg="mod">
-          <ac:chgData name="Clover Sin I Chang (Stinson Communications Inc)" userId="73b31ea9-7b99-4cbb-9f95-6d9e36522bc0" providerId="ADAL" clId="{9ACEEF60-B8C4-4D3A-B0A8-7FADAC6D59DB}" dt="2026-09-01T15:04:42.200" v="14" actId="20577"/>
-          <ac:spMkLst>
-            <pc:docMk/>
-            <pc:sldMk cId="1428960468" sldId="2147479561"/>
-            <ac:spMk id="4" creationId="{8020CF76-55FC-64E2-BF44-7835621D022B}"/>
-          </ac:spMkLst>
-        </pc:spChg>
-        <pc:spChg chg="del mod">
-          <ac:chgData name="Clover Sin I Chang (Stinson Communications Inc)" userId="73b31ea9-7b99-4cbb-9f95-6d9e36522bc0" providerId="ADAL" clId="{9ACEEF60-B8C4-4D3A-B0A8-7FADAC6D59DB}" dt="2026-09-01T15:11:00.604" v="187" actId="478"/>
-          <ac:spMkLst>
-            <pc:docMk/>
-            <pc:sldMk cId="1428960468" sldId="2147479561"/>
-            <ac:spMk id="5" creationId="{017272F2-BB57-AD56-AA97-8470259B90F2}"/>
-          </ac:spMkLst>
-        </pc:spChg>
-        <pc:spChg chg="del">
-          <ac:chgData name="Clover Sin I Chang (Stinson Communications Inc)" userId="73b31ea9-7b99-4cbb-9f95-6d9e36522bc0" providerId="ADAL" clId="{9ACEEF60-B8C4-4D3A-B0A8-7FADAC6D59DB}" dt="2026-09-01T15:11:04.178" v="188" actId="478"/>
-          <ac:spMkLst>
-            <pc:docMk/>
-            <pc:sldMk cId="1428960468" sldId="2147479561"/>
-            <ac:spMk id="6" creationId="{E91E5057-7134-96FF-08ED-506441CE61BA}"/>
-          </ac:spMkLst>
-        </pc:spChg>
-        <pc:spChg chg="mod">
-          <ac:chgData name="Clover Sin I Chang (Stinson Communications Inc)" userId="73b31ea9-7b99-4cbb-9f95-6d9e36522bc0" providerId="ADAL" clId="{9ACEEF60-B8C4-4D3A-B0A8-7FADAC6D59DB}" dt="2026-09-01T15:04:40.715" v="13" actId="20577"/>
-          <ac:spMkLst>
-            <pc:docMk/>
-            <pc:sldMk cId="1428960468" sldId="2147479561"/>
-            <ac:spMk id="14" creationId="{5DD4083D-AA84-07FC-B820-98DEE7E4715A}"/>
-          </ac:spMkLst>
-        </pc:spChg>
-        <pc:spChg chg="mod">
-          <ac:chgData name="Clover Sin I Chang (Stinson Communications Inc)" userId="73b31ea9-7b99-4cbb-9f95-6d9e36522bc0" providerId="ADAL" clId="{9ACEEF60-B8C4-4D3A-B0A8-7FADAC6D59DB}" dt="2026-09-01T15:04:43.409" v="15" actId="20577"/>
-          <ac:spMkLst>
-            <pc:docMk/>
-            <pc:sldMk cId="1428960468" sldId="2147479561"/>
-            <ac:spMk id="15" creationId="{EC8C2D5C-21FA-ED7D-8D17-29B6D4DB46CF}"/>
-          </ac:spMkLst>
-        </pc:spChg>
-        <pc:spChg chg="mod ord">
-          <ac:chgData name="Clover Sin I Chang (Stinson Communications Inc)" userId="73b31ea9-7b99-4cbb-9f95-6d9e36522bc0" providerId="ADAL" clId="{9ACEEF60-B8C4-4D3A-B0A8-7FADAC6D59DB}" dt="2026-09-01T15:11:24.598" v="195" actId="13244"/>
-          <ac:spMkLst>
-            <pc:docMk/>
-            <pc:sldMk cId="1428960468" sldId="2147479561"/>
-            <ac:spMk id="16" creationId="{E67C7D4B-4C6E-0D7F-C35F-F71BF94D0951}"/>
-          </ac:spMkLst>
-        </pc:spChg>
-        <pc:spChg chg="ord">
-          <ac:chgData name="Clover Sin I Chang (Stinson Communications Inc)" userId="73b31ea9-7b99-4cbb-9f95-6d9e36522bc0" providerId="ADAL" clId="{9ACEEF60-B8C4-4D3A-B0A8-7FADAC6D59DB}" dt="2026-09-01T15:11:29.999" v="196" actId="13244"/>
-          <ac:spMkLst>
-            <pc:docMk/>
-            <pc:sldMk cId="1428960468" sldId="2147479561"/>
-            <ac:spMk id="17" creationId="{EA8BDC94-9FDE-CA90-45DD-CA7F107DE659}"/>
-          </ac:spMkLst>
-        </pc:spChg>
-        <pc:spChg chg="ord topLvl">
-          <ac:chgData name="Clover Sin I Chang (Stinson Communications Inc)" userId="73b31ea9-7b99-4cbb-9f95-6d9e36522bc0" providerId="ADAL" clId="{9ACEEF60-B8C4-4D3A-B0A8-7FADAC6D59DB}" dt="2026-09-01T15:11:21.058" v="193" actId="13244"/>
-          <ac:spMkLst>
-            <pc:docMk/>
-            <pc:sldMk cId="1428960468" sldId="2147479561"/>
-            <ac:spMk id="20" creationId="{85A9BBEA-DFAF-FA8A-CA49-5BEAAF861C72}"/>
-          </ac:spMkLst>
-        </pc:spChg>
-        <pc:spChg chg="ord topLvl">
-          <ac:chgData name="Clover Sin I Chang (Stinson Communications Inc)" userId="73b31ea9-7b99-4cbb-9f95-6d9e36522bc0" providerId="ADAL" clId="{9ACEEF60-B8C4-4D3A-B0A8-7FADAC6D59DB}" dt="2026-09-01T15:11:22.397" v="194" actId="13244"/>
-          <ac:spMkLst>
-            <pc:docMk/>
-            <pc:sldMk cId="1428960468" sldId="2147479561"/>
-            <ac:spMk id="21" creationId="{EA215468-C243-45D4-6E41-2E63409CA529}"/>
-          </ac:spMkLst>
-        </pc:spChg>
-        <pc:grpChg chg="del">
-          <ac:chgData name="Clover Sin I Chang (Stinson Communications Inc)" userId="73b31ea9-7b99-4cbb-9f95-6d9e36522bc0" providerId="ADAL" clId="{9ACEEF60-B8C4-4D3A-B0A8-7FADAC6D59DB}" dt="2026-09-01T15:10:04.879" v="153" actId="165"/>
-          <ac:grpSpMkLst>
-            <pc:docMk/>
-            <pc:sldMk cId="1428960468" sldId="2147479561"/>
-            <ac:grpSpMk id="19" creationId="{11E84844-FC59-B616-4633-99705DA19FAA}"/>
-          </ac:grpSpMkLst>
-        </pc:grpChg>
-        <pc:cxnChg chg="ord">
-          <ac:chgData name="Clover Sin I Chang (Stinson Communications Inc)" userId="73b31ea9-7b99-4cbb-9f95-6d9e36522bc0" providerId="ADAL" clId="{9ACEEF60-B8C4-4D3A-B0A8-7FADAC6D59DB}" dt="2026-09-01T15:11:34.409" v="197" actId="13244"/>
-          <ac:cxnSpMkLst>
-            <pc:docMk/>
-            <pc:sldMk cId="1428960468" sldId="2147479561"/>
-            <ac:cxnSpMk id="27" creationId="{B0D551DB-F3DD-101E-ABB6-CB3BA48C273F}"/>
-          </ac:cxnSpMkLst>
-        </pc:cxnChg>
-        <pc:cxnChg chg="ord">
-          <ac:chgData name="Clover Sin I Chang (Stinson Communications Inc)" userId="73b31ea9-7b99-4cbb-9f95-6d9e36522bc0" providerId="ADAL" clId="{9ACEEF60-B8C4-4D3A-B0A8-7FADAC6D59DB}" dt="2026-09-01T15:11:35.310" v="198" actId="13244"/>
-          <ac:cxnSpMkLst>
-            <pc:docMk/>
-            <pc:sldMk cId="1428960468" sldId="2147479561"/>
-            <ac:cxnSpMk id="30" creationId="{669D786F-C3F2-B509-8DD0-612E02AE34FB}"/>
-          </ac:cxnSpMkLst>
-        </pc:cxnChg>
-      </pc:sldChg>
-      <pc:sldChg chg="addSp delSp modSp add del mod delAnim modAnim">
-        <pc:chgData name="Clover Sin I Chang (Stinson Communications Inc)" userId="73b31ea9-7b99-4cbb-9f95-6d9e36522bc0" providerId="ADAL" clId="{9ACEEF60-B8C4-4D3A-B0A8-7FADAC6D59DB}" dt="2026-09-01T15:12:21.662" v="204" actId="13244"/>
-        <pc:sldMkLst>
-          <pc:docMk/>
-          <pc:sldMk cId="0" sldId="2147479562"/>
-        </pc:sldMkLst>
-        <pc:spChg chg="add del mod">
-          <ac:chgData name="Clover Sin I Chang (Stinson Communications Inc)" userId="73b31ea9-7b99-4cbb-9f95-6d9e36522bc0" providerId="ADAL" clId="{9ACEEF60-B8C4-4D3A-B0A8-7FADAC6D59DB}" dt="2026-09-01T15:08:08.063" v="51" actId="478"/>
-          <ac:spMkLst>
-            <pc:docMk/>
-            <pc:sldMk cId="0" sldId="2147479562"/>
-            <ac:spMk id="3" creationId="{6B291FDC-BD00-B390-D73D-2D74FCA9DB5D}"/>
-          </ac:spMkLst>
-        </pc:spChg>
-        <pc:spChg chg="del mod">
-          <ac:chgData name="Clover Sin I Chang (Stinson Communications Inc)" userId="73b31ea9-7b99-4cbb-9f95-6d9e36522bc0" providerId="ADAL" clId="{9ACEEF60-B8C4-4D3A-B0A8-7FADAC6D59DB}" dt="2026-09-01T15:11:43.052" v="200" actId="478"/>
-          <ac:spMkLst>
-            <pc:docMk/>
-            <pc:sldMk cId="0" sldId="2147479562"/>
-            <ac:spMk id="5" creationId="{00000000-0000-0000-0000-000000000000}"/>
-          </ac:spMkLst>
-        </pc:spChg>
-        <pc:spChg chg="add del mod">
-          <ac:chgData name="Clover Sin I Chang (Stinson Communications Inc)" userId="73b31ea9-7b99-4cbb-9f95-6d9e36522bc0" providerId="ADAL" clId="{9ACEEF60-B8C4-4D3A-B0A8-7FADAC6D59DB}" dt="2026-09-01T15:09:19.216" v="151" actId="478"/>
-          <ac:spMkLst>
-            <pc:docMk/>
-            <pc:sldMk cId="0" sldId="2147479562"/>
-            <ac:spMk id="7" creationId="{D04AC515-A616-6B10-CC7C-D47EF879B21A}"/>
-          </ac:spMkLst>
-        </pc:spChg>
-        <pc:spChg chg="mod">
-          <ac:chgData name="Clover Sin I Chang (Stinson Communications Inc)" userId="73b31ea9-7b99-4cbb-9f95-6d9e36522bc0" providerId="ADAL" clId="{9ACEEF60-B8C4-4D3A-B0A8-7FADAC6D59DB}" dt="2026-09-01T15:09:15.614" v="150" actId="108"/>
-          <ac:spMkLst>
-            <pc:docMk/>
-            <pc:sldMk cId="0" sldId="2147479562"/>
-            <ac:spMk id="22" creationId="{00000000-0000-0000-0000-000000000000}"/>
-          </ac:spMkLst>
-        </pc:spChg>
-        <pc:spChg chg="mod">
-          <ac:chgData name="Clover Sin I Chang (Stinson Communications Inc)" userId="73b31ea9-7b99-4cbb-9f95-6d9e36522bc0" providerId="ADAL" clId="{9ACEEF60-B8C4-4D3A-B0A8-7FADAC6D59DB}" dt="2026-09-01T15:11:48.395" v="201" actId="1035"/>
-          <ac:spMkLst>
-            <pc:docMk/>
-            <pc:sldMk cId="0" sldId="2147479562"/>
-            <ac:spMk id="23" creationId="{95DECB81-910E-E3C0-DF6E-BA14DA16645C}"/>
-          </ac:spMkLst>
-        </pc:spChg>
-        <pc:spChg chg="mod">
-          <ac:chgData name="Clover Sin I Chang (Stinson Communications Inc)" userId="73b31ea9-7b99-4cbb-9f95-6d9e36522bc0" providerId="ADAL" clId="{9ACEEF60-B8C4-4D3A-B0A8-7FADAC6D59DB}" dt="2026-09-01T15:10:22.003" v="157" actId="962"/>
-          <ac:spMkLst>
-            <pc:docMk/>
-            <pc:sldMk cId="0" sldId="2147479562"/>
-            <ac:spMk id="24" creationId="{CAED84DD-70FB-7D23-AF5F-FF11BA9644C8}"/>
-          </ac:spMkLst>
-        </pc:spChg>
-        <pc:spChg chg="mod">
-          <ac:chgData name="Clover Sin I Chang (Stinson Communications Inc)" userId="73b31ea9-7b99-4cbb-9f95-6d9e36522bc0" providerId="ADAL" clId="{9ACEEF60-B8C4-4D3A-B0A8-7FADAC6D59DB}" dt="2026-09-01T15:10:22.755" v="158" actId="962"/>
-          <ac:spMkLst>
-            <pc:docMk/>
-            <pc:sldMk cId="0" sldId="2147479562"/>
-            <ac:spMk id="25" creationId="{EBFBA0F4-36F6-BFFA-4B72-848B1052F76C}"/>
-          </ac:spMkLst>
-        </pc:spChg>
-        <pc:grpChg chg="mod ord">
-          <ac:chgData name="Clover Sin I Chang (Stinson Communications Inc)" userId="73b31ea9-7b99-4cbb-9f95-6d9e36522bc0" providerId="ADAL" clId="{9ACEEF60-B8C4-4D3A-B0A8-7FADAC6D59DB}" dt="2026-09-01T15:12:07.399" v="202" actId="166"/>
-          <ac:grpSpMkLst>
-            <pc:docMk/>
-            <pc:sldMk cId="0" sldId="2147479562"/>
-            <ac:grpSpMk id="43" creationId="{3BE8704A-A294-C911-24E7-48BD3FEEE64E}"/>
-          </ac:grpSpMkLst>
-        </pc:grpChg>
-        <pc:grpChg chg="mod ord">
-          <ac:chgData name="Clover Sin I Chang (Stinson Communications Inc)" userId="73b31ea9-7b99-4cbb-9f95-6d9e36522bc0" providerId="ADAL" clId="{9ACEEF60-B8C4-4D3A-B0A8-7FADAC6D59DB}" dt="2026-09-01T15:12:18.136" v="203" actId="13244"/>
-          <ac:grpSpMkLst>
-            <pc:docMk/>
-            <pc:sldMk cId="0" sldId="2147479562"/>
-            <ac:grpSpMk id="44" creationId="{2FE38DEE-6C0E-DC52-97BF-E2DB452F09FF}"/>
-          </ac:grpSpMkLst>
-        </pc:grpChg>
-        <pc:grpChg chg="mod ord">
-          <ac:chgData name="Clover Sin I Chang (Stinson Communications Inc)" userId="73b31ea9-7b99-4cbb-9f95-6d9e36522bc0" providerId="ADAL" clId="{9ACEEF60-B8C4-4D3A-B0A8-7FADAC6D59DB}" dt="2026-09-01T15:12:21.662" v="204" actId="13244"/>
-          <ac:grpSpMkLst>
-            <pc:docMk/>
-            <pc:sldMk cId="0" sldId="2147479562"/>
-            <ac:grpSpMk id="45" creationId="{28AEAC1D-8F04-E2C4-C1EF-004B6BF17B2F}"/>
-          </ac:grpSpMkLst>
-        </pc:grpChg>
-        <pc:grpChg chg="mod">
-          <ac:chgData name="Clover Sin I Chang (Stinson Communications Inc)" userId="73b31ea9-7b99-4cbb-9f95-6d9e36522bc0" providerId="ADAL" clId="{9ACEEF60-B8C4-4D3A-B0A8-7FADAC6D59DB}" dt="2026-09-01T15:10:27.835" v="162" actId="962"/>
-          <ac:grpSpMkLst>
-            <pc:docMk/>
-            <pc:sldMk cId="0" sldId="2147479562"/>
-            <ac:grpSpMk id="49" creationId="{DD916110-86D3-E29A-3E3F-10FB2876EF43}"/>
-          </ac:grpSpMkLst>
-        </pc:grpChg>
-        <pc:cxnChg chg="mod">
-          <ac:chgData name="Clover Sin I Chang (Stinson Communications Inc)" userId="73b31ea9-7b99-4cbb-9f95-6d9e36522bc0" providerId="ADAL" clId="{9ACEEF60-B8C4-4D3A-B0A8-7FADAC6D59DB}" dt="2026-09-01T15:08:17.865" v="53" actId="1076"/>
-          <ac:cxnSpMkLst>
-            <pc:docMk/>
-            <pc:sldMk cId="0" sldId="2147479562"/>
-            <ac:cxnSpMk id="46" creationId="{7A52F403-1B61-FACA-73B8-A27AC547A02F}"/>
-          </ac:cxnSpMkLst>
-        </pc:cxnChg>
-        <pc:cxnChg chg="mod">
-          <ac:chgData name="Clover Sin I Chang (Stinson Communications Inc)" userId="73b31ea9-7b99-4cbb-9f95-6d9e36522bc0" providerId="ADAL" clId="{9ACEEF60-B8C4-4D3A-B0A8-7FADAC6D59DB}" dt="2026-09-01T15:08:20.179" v="54" actId="1076"/>
-          <ac:cxnSpMkLst>
-            <pc:docMk/>
-            <pc:sldMk cId="0" sldId="2147479562"/>
-            <ac:cxnSpMk id="48" creationId="{BA52A9FD-2B46-02E8-06EB-57B33075E40E}"/>
-          </ac:cxnSpMkLst>
-        </pc:cxnChg>
-      </pc:sldChg>
-      <pc:sldChg chg="modSp add mod">
-        <pc:chgData name="Clover Sin I Chang (Stinson Communications Inc)" userId="73b31ea9-7b99-4cbb-9f95-6d9e36522bc0" providerId="ADAL" clId="{9ACEEF60-B8C4-4D3A-B0A8-7FADAC6D59DB}" dt="2026-09-01T15:13:07.534" v="212" actId="13244"/>
-        <pc:sldMkLst>
-          <pc:docMk/>
-          <pc:sldMk cId="0" sldId="2147479563"/>
-        </pc:sldMkLst>
-        <pc:spChg chg="ord">
-          <ac:chgData name="Clover Sin I Chang (Stinson Communications Inc)" userId="73b31ea9-7b99-4cbb-9f95-6d9e36522bc0" providerId="ADAL" clId="{9ACEEF60-B8C4-4D3A-B0A8-7FADAC6D59DB}" dt="2026-09-01T15:12:49.918" v="208" actId="13244"/>
-          <ac:spMkLst>
-            <pc:docMk/>
-            <pc:sldMk cId="0" sldId="2147479563"/>
-            <ac:spMk id="4" creationId="{0A8F01B1-A7D9-8FE3-4167-B9CA3D91B806}"/>
-          </ac:spMkLst>
-        </pc:spChg>
-        <pc:spChg chg="mod">
-          <ac:chgData name="Clover Sin I Chang (Stinson Communications Inc)" userId="73b31ea9-7b99-4cbb-9f95-6d9e36522bc0" providerId="ADAL" clId="{9ACEEF60-B8C4-4D3A-B0A8-7FADAC6D59DB}" dt="2026-09-01T15:05:18.484" v="24" actId="20577"/>
-          <ac:spMkLst>
-            <pc:docMk/>
-            <pc:sldMk cId="0" sldId="2147479563"/>
-            <ac:spMk id="31" creationId="{C7FA6D91-B192-8F23-C6A9-E0023B42FEF4}"/>
-          </ac:spMkLst>
-        </pc:spChg>
-        <pc:spChg chg="mod">
-          <ac:chgData name="Clover Sin I Chang (Stinson Communications Inc)" userId="73b31ea9-7b99-4cbb-9f95-6d9e36522bc0" providerId="ADAL" clId="{9ACEEF60-B8C4-4D3A-B0A8-7FADAC6D59DB}" dt="2026-09-01T15:05:16.103" v="23" actId="20577"/>
-          <ac:spMkLst>
-            <pc:docMk/>
-            <pc:sldMk cId="0" sldId="2147479563"/>
-            <ac:spMk id="32" creationId="{ECB2875E-C9DE-F624-2E3F-132125D47542}"/>
-          </ac:spMkLst>
-        </pc:spChg>
-        <pc:spChg chg="mod">
-          <ac:chgData name="Clover Sin I Chang (Stinson Communications Inc)" userId="73b31ea9-7b99-4cbb-9f95-6d9e36522bc0" providerId="ADAL" clId="{9ACEEF60-B8C4-4D3A-B0A8-7FADAC6D59DB}" dt="2026-09-01T15:05:15.113" v="22" actId="20577"/>
-          <ac:spMkLst>
-            <pc:docMk/>
-            <pc:sldMk cId="0" sldId="2147479563"/>
-            <ac:spMk id="33" creationId="{9FE41BBC-5EEF-25D5-D6C1-4CC6D848C2A3}"/>
-          </ac:spMkLst>
-        </pc:spChg>
-        <pc:picChg chg="mod ord">
-          <ac:chgData name="Clover Sin I Chang (Stinson Communications Inc)" userId="73b31ea9-7b99-4cbb-9f95-6d9e36522bc0" providerId="ADAL" clId="{9ACEEF60-B8C4-4D3A-B0A8-7FADAC6D59DB}" dt="2026-09-01T15:12:54.405" v="211" actId="13244"/>
-          <ac:picMkLst>
-            <pc:docMk/>
-            <pc:sldMk cId="0" sldId="2147479563"/>
-            <ac:picMk id="35" creationId="{18300A72-E8C2-CCB5-93CA-65E08E225701}"/>
-          </ac:picMkLst>
-        </pc:picChg>
-        <pc:picChg chg="mod ord">
-          <ac:chgData name="Clover Sin I Chang (Stinson Communications Inc)" userId="73b31ea9-7b99-4cbb-9f95-6d9e36522bc0" providerId="ADAL" clId="{9ACEEF60-B8C4-4D3A-B0A8-7FADAC6D59DB}" dt="2026-09-01T15:12:45.859" v="206" actId="13244"/>
-          <ac:picMkLst>
-            <pc:docMk/>
-            <pc:sldMk cId="0" sldId="2147479563"/>
-            <ac:picMk id="39" creationId="{A6BCCEC4-0A36-B0C8-D817-C10C3BC73E47}"/>
-          </ac:picMkLst>
-        </pc:picChg>
-        <pc:picChg chg="mod ord">
-          <ac:chgData name="Clover Sin I Chang (Stinson Communications Inc)" userId="73b31ea9-7b99-4cbb-9f95-6d9e36522bc0" providerId="ADAL" clId="{9ACEEF60-B8C4-4D3A-B0A8-7FADAC6D59DB}" dt="2026-09-01T15:13:07.534" v="212" actId="13244"/>
-          <ac:picMkLst>
-            <pc:docMk/>
-            <pc:sldMk cId="0" sldId="2147479563"/>
-            <ac:picMk id="41" creationId="{BB570CA4-DC80-03A3-2A4B-3E00C6EA1F9F}"/>
-          </ac:picMkLst>
-        </pc:picChg>
-      </pc:sldChg>
-      <pc:sldChg chg="modSp add mod">
-        <pc:chgData name="Clover Sin I Chang (Stinson Communications Inc)" userId="73b31ea9-7b99-4cbb-9f95-6d9e36522bc0" providerId="ADAL" clId="{9ACEEF60-B8C4-4D3A-B0A8-7FADAC6D59DB}" dt="2026-09-01T15:13:58.475" v="222" actId="13244"/>
-        <pc:sldMkLst>
-          <pc:docMk/>
-          <pc:sldMk cId="0" sldId="2147479564"/>
-        </pc:sldMkLst>
-        <pc:spChg chg="mod">
-          <ac:chgData name="Clover Sin I Chang (Stinson Communications Inc)" userId="73b31ea9-7b99-4cbb-9f95-6d9e36522bc0" providerId="ADAL" clId="{9ACEEF60-B8C4-4D3A-B0A8-7FADAC6D59DB}" dt="2026-09-01T15:10:31.344" v="166" actId="962"/>
-          <ac:spMkLst>
-            <pc:docMk/>
-            <pc:sldMk cId="0" sldId="2147479564"/>
-            <ac:spMk id="5" creationId="{513C55F7-7DC6-9331-4A46-DEFCB15B94E8}"/>
-          </ac:spMkLst>
-        </pc:spChg>
-        <pc:spChg chg="ord">
-          <ac:chgData name="Clover Sin I Chang (Stinson Communications Inc)" userId="73b31ea9-7b99-4cbb-9f95-6d9e36522bc0" providerId="ADAL" clId="{9ACEEF60-B8C4-4D3A-B0A8-7FADAC6D59DB}" dt="2026-09-01T15:13:19.142" v="213" actId="13244"/>
-          <ac:spMkLst>
-            <pc:docMk/>
-            <pc:sldMk cId="0" sldId="2147479564"/>
-            <ac:spMk id="39" creationId="{00000000-0000-0000-0000-000000000000}"/>
-          </ac:spMkLst>
-        </pc:spChg>
-        <pc:spChg chg="mod">
-          <ac:chgData name="Clover Sin I Chang (Stinson Communications Inc)" userId="73b31ea9-7b99-4cbb-9f95-6d9e36522bc0" providerId="ADAL" clId="{9ACEEF60-B8C4-4D3A-B0A8-7FADAC6D59DB}" dt="2026-09-01T15:10:32.148" v="167" actId="962"/>
-          <ac:spMkLst>
-            <pc:docMk/>
-            <pc:sldMk cId="0" sldId="2147479564"/>
-            <ac:spMk id="40" creationId="{7AB9715E-563D-C6DA-C6CA-45A4428E108C}"/>
-          </ac:spMkLst>
-        </pc:spChg>
-        <pc:spChg chg="mod">
-          <ac:chgData name="Clover Sin I Chang (Stinson Communications Inc)" userId="73b31ea9-7b99-4cbb-9f95-6d9e36522bc0" providerId="ADAL" clId="{9ACEEF60-B8C4-4D3A-B0A8-7FADAC6D59DB}" dt="2026-09-01T15:10:32.809" v="168" actId="962"/>
-          <ac:spMkLst>
-            <pc:docMk/>
-            <pc:sldMk cId="0" sldId="2147479564"/>
-            <ac:spMk id="41" creationId="{F05D448E-DE8F-E8ED-8B58-A27BCA20156B}"/>
-          </ac:spMkLst>
-        </pc:spChg>
-        <pc:spChg chg="mod">
-          <ac:chgData name="Clover Sin I Chang (Stinson Communications Inc)" userId="73b31ea9-7b99-4cbb-9f95-6d9e36522bc0" providerId="ADAL" clId="{9ACEEF60-B8C4-4D3A-B0A8-7FADAC6D59DB}" dt="2026-09-01T15:10:33.408" v="169" actId="962"/>
-          <ac:spMkLst>
-            <pc:docMk/>
-            <pc:sldMk cId="0" sldId="2147479564"/>
-            <ac:spMk id="42" creationId="{92DC36A8-3CAA-55BA-5CC9-025D81CFF507}"/>
-          </ac:spMkLst>
-        </pc:spChg>
-        <pc:spChg chg="mod">
-          <ac:chgData name="Clover Sin I Chang (Stinson Communications Inc)" userId="73b31ea9-7b99-4cbb-9f95-6d9e36522bc0" providerId="ADAL" clId="{9ACEEF60-B8C4-4D3A-B0A8-7FADAC6D59DB}" dt="2026-09-01T15:10:33.987" v="170" actId="962"/>
-          <ac:spMkLst>
-            <pc:docMk/>
-            <pc:sldMk cId="0" sldId="2147479564"/>
-            <ac:spMk id="44" creationId="{FFDED5E1-39DC-C1E4-616D-C281C5AA3C9A}"/>
-          </ac:spMkLst>
-        </pc:spChg>
-        <pc:spChg chg="ord">
-          <ac:chgData name="Clover Sin I Chang (Stinson Communications Inc)" userId="73b31ea9-7b99-4cbb-9f95-6d9e36522bc0" providerId="ADAL" clId="{9ACEEF60-B8C4-4D3A-B0A8-7FADAC6D59DB}" dt="2026-09-01T15:13:34.013" v="214" actId="13244"/>
-          <ac:spMkLst>
-            <pc:docMk/>
-            <pc:sldMk cId="0" sldId="2147479564"/>
-            <ac:spMk id="56" creationId="{F923C053-6A78-1B5F-1CCC-F4AA4A5623C7}"/>
-          </ac:spMkLst>
-        </pc:spChg>
-        <pc:spChg chg="ord">
-          <ac:chgData name="Clover Sin I Chang (Stinson Communications Inc)" userId="73b31ea9-7b99-4cbb-9f95-6d9e36522bc0" providerId="ADAL" clId="{9ACEEF60-B8C4-4D3A-B0A8-7FADAC6D59DB}" dt="2026-09-01T15:13:36.868" v="215" actId="13244"/>
-          <ac:spMkLst>
-            <pc:docMk/>
-            <pc:sldMk cId="0" sldId="2147479564"/>
-            <ac:spMk id="57" creationId="{83A6BE4E-D7E5-3851-AFBA-7849310A81AD}"/>
-          </ac:spMkLst>
-        </pc:spChg>
-        <pc:spChg chg="ord">
-          <ac:chgData name="Clover Sin I Chang (Stinson Communications Inc)" userId="73b31ea9-7b99-4cbb-9f95-6d9e36522bc0" providerId="ADAL" clId="{9ACEEF60-B8C4-4D3A-B0A8-7FADAC6D59DB}" dt="2026-09-01T15:13:38.339" v="216" actId="13244"/>
-          <ac:spMkLst>
-            <pc:docMk/>
-            <pc:sldMk cId="0" sldId="2147479564"/>
-            <ac:spMk id="58" creationId="{62FA60A3-BF38-E942-4898-B9445F4F50B6}"/>
-          </ac:spMkLst>
-        </pc:spChg>
-        <pc:spChg chg="ord">
-          <ac:chgData name="Clover Sin I Chang (Stinson Communications Inc)" userId="73b31ea9-7b99-4cbb-9f95-6d9e36522bc0" providerId="ADAL" clId="{9ACEEF60-B8C4-4D3A-B0A8-7FADAC6D59DB}" dt="2026-09-01T15:13:39.877" v="217" actId="13244"/>
-          <ac:spMkLst>
-            <pc:docMk/>
-            <pc:sldMk cId="0" sldId="2147479564"/>
-            <ac:spMk id="59" creationId="{E74B3941-CAF1-FC61-D001-3285D215F93C}"/>
-          </ac:spMkLst>
-        </pc:spChg>
-        <pc:spChg chg="ord">
-          <ac:chgData name="Clover Sin I Chang (Stinson Communications Inc)" userId="73b31ea9-7b99-4cbb-9f95-6d9e36522bc0" providerId="ADAL" clId="{9ACEEF60-B8C4-4D3A-B0A8-7FADAC6D59DB}" dt="2026-09-01T15:13:41.362" v="218" actId="13244"/>
-          <ac:spMkLst>
-            <pc:docMk/>
-            <pc:sldMk cId="0" sldId="2147479564"/>
-            <ac:spMk id="60" creationId="{611D751E-13B5-E92B-873F-C9FDF0E06FC8}"/>
-          </ac:spMkLst>
-        </pc:spChg>
-        <pc:cxnChg chg="ord">
-          <ac:chgData name="Clover Sin I Chang (Stinson Communications Inc)" userId="73b31ea9-7b99-4cbb-9f95-6d9e36522bc0" providerId="ADAL" clId="{9ACEEF60-B8C4-4D3A-B0A8-7FADAC6D59DB}" dt="2026-09-01T15:13:53.357" v="219" actId="13244"/>
-          <ac:cxnSpMkLst>
-            <pc:docMk/>
-            <pc:sldMk cId="0" sldId="2147479564"/>
-            <ac:cxnSpMk id="61" creationId="{413E8D9A-F9F7-E372-6290-04774D72F187}"/>
-          </ac:cxnSpMkLst>
-        </pc:cxnChg>
-        <pc:cxnChg chg="ord">
-          <ac:chgData name="Clover Sin I Chang (Stinson Communications Inc)" userId="73b31ea9-7b99-4cbb-9f95-6d9e36522bc0" providerId="ADAL" clId="{9ACEEF60-B8C4-4D3A-B0A8-7FADAC6D59DB}" dt="2026-09-01T15:13:55.023" v="220" actId="13244"/>
-          <ac:cxnSpMkLst>
-            <pc:docMk/>
-            <pc:sldMk cId="0" sldId="2147479564"/>
-            <ac:cxnSpMk id="62" creationId="{AD4BE0D2-D536-82E0-901F-019E66FC7CCE}"/>
-          </ac:cxnSpMkLst>
-        </pc:cxnChg>
-        <pc:cxnChg chg="ord">
-          <ac:chgData name="Clover Sin I Chang (Stinson Communications Inc)" userId="73b31ea9-7b99-4cbb-9f95-6d9e36522bc0" providerId="ADAL" clId="{9ACEEF60-B8C4-4D3A-B0A8-7FADAC6D59DB}" dt="2026-09-01T15:13:56.727" v="221" actId="13244"/>
-          <ac:cxnSpMkLst>
-            <pc:docMk/>
-            <pc:sldMk cId="0" sldId="2147479564"/>
-            <ac:cxnSpMk id="63" creationId="{A8896D55-1A42-9223-D7C4-62206990398E}"/>
-          </ac:cxnSpMkLst>
-        </pc:cxnChg>
-        <pc:cxnChg chg="ord">
-          <ac:chgData name="Clover Sin I Chang (Stinson Communications Inc)" userId="73b31ea9-7b99-4cbb-9f95-6d9e36522bc0" providerId="ADAL" clId="{9ACEEF60-B8C4-4D3A-B0A8-7FADAC6D59DB}" dt="2026-09-01T15:13:58.475" v="222" actId="13244"/>
-          <ac:cxnSpMkLst>
-            <pc:docMk/>
-            <pc:sldMk cId="0" sldId="2147479564"/>
-            <ac:cxnSpMk id="64" creationId="{D1C77D07-BB07-06E2-5A0C-B316EA640AFB}"/>
-          </ac:cxnSpMkLst>
-        </pc:cxnChg>
-      </pc:sldChg>
-      <pc:sldChg chg="modSp add mod">
-        <pc:chgData name="Clover Sin I Chang (Stinson Communications Inc)" userId="73b31ea9-7b99-4cbb-9f95-6d9e36522bc0" providerId="ADAL" clId="{9ACEEF60-B8C4-4D3A-B0A8-7FADAC6D59DB}" dt="2026-09-01T15:14:19.255" v="229" actId="13244"/>
-        <pc:sldMkLst>
-          <pc:docMk/>
-          <pc:sldMk cId="0" sldId="2147479565"/>
-        </pc:sldMkLst>
-        <pc:spChg chg="ord">
-          <ac:chgData name="Clover Sin I Chang (Stinson Communications Inc)" userId="73b31ea9-7b99-4cbb-9f95-6d9e36522bc0" providerId="ADAL" clId="{9ACEEF60-B8C4-4D3A-B0A8-7FADAC6D59DB}" dt="2026-09-01T15:14:04.381" v="223" actId="13244"/>
-          <ac:spMkLst>
-            <pc:docMk/>
-            <pc:sldMk cId="0" sldId="2147479565"/>
-            <ac:spMk id="2" creationId="{9C5A4D7B-886F-C95E-7398-6938D1C1A64F}"/>
-          </ac:spMkLst>
-        </pc:spChg>
-        <pc:spChg chg="ord">
-          <ac:chgData name="Clover Sin I Chang (Stinson Communications Inc)" userId="73b31ea9-7b99-4cbb-9f95-6d9e36522bc0" providerId="ADAL" clId="{9ACEEF60-B8C4-4D3A-B0A8-7FADAC6D59DB}" dt="2026-09-01T15:14:06.700" v="224" actId="13244"/>
-          <ac:spMkLst>
-            <pc:docMk/>
-            <pc:sldMk cId="0" sldId="2147479565"/>
-            <ac:spMk id="4" creationId="{CC5CA827-900A-D24B-E8FC-A3ADA7DA1632}"/>
-          </ac:spMkLst>
-        </pc:spChg>
-        <pc:spChg chg="ord">
-          <ac:chgData name="Clover Sin I Chang (Stinson Communications Inc)" userId="73b31ea9-7b99-4cbb-9f95-6d9e36522bc0" providerId="ADAL" clId="{9ACEEF60-B8C4-4D3A-B0A8-7FADAC6D59DB}" dt="2026-09-01T15:14:11.365" v="225" actId="13244"/>
-          <ac:spMkLst>
-            <pc:docMk/>
-            <pc:sldMk cId="0" sldId="2147479565"/>
-            <ac:spMk id="6" creationId="{C8E7FD6F-AD91-4578-F1E3-BF52FACD9AD9}"/>
-          </ac:spMkLst>
-        </pc:spChg>
-        <pc:spChg chg="ord">
-          <ac:chgData name="Clover Sin I Chang (Stinson Communications Inc)" userId="73b31ea9-7b99-4cbb-9f95-6d9e36522bc0" providerId="ADAL" clId="{9ACEEF60-B8C4-4D3A-B0A8-7FADAC6D59DB}" dt="2026-09-01T15:14:12.520" v="226" actId="13244"/>
-          <ac:spMkLst>
-            <pc:docMk/>
-            <pc:sldMk cId="0" sldId="2147479565"/>
-            <ac:spMk id="29" creationId="{4448AE10-AA48-F8DC-4E67-32C7C36BE94E}"/>
-          </ac:spMkLst>
-        </pc:spChg>
-        <pc:spChg chg="ord">
-          <ac:chgData name="Clover Sin I Chang (Stinson Communications Inc)" userId="73b31ea9-7b99-4cbb-9f95-6d9e36522bc0" providerId="ADAL" clId="{9ACEEF60-B8C4-4D3A-B0A8-7FADAC6D59DB}" dt="2026-09-01T15:14:13.990" v="227" actId="13244"/>
-          <ac:spMkLst>
-            <pc:docMk/>
-            <pc:sldMk cId="0" sldId="2147479565"/>
-            <ac:spMk id="30" creationId="{89C88FCC-F4FC-FF55-E713-7E2DC9A83053}"/>
-          </ac:spMkLst>
-        </pc:spChg>
-        <pc:spChg chg="ord">
-          <ac:chgData name="Clover Sin I Chang (Stinson Communications Inc)" userId="73b31ea9-7b99-4cbb-9f95-6d9e36522bc0" providerId="ADAL" clId="{9ACEEF60-B8C4-4D3A-B0A8-7FADAC6D59DB}" dt="2026-09-01T15:14:15.235" v="228" actId="13244"/>
-          <ac:spMkLst>
-            <pc:docMk/>
-            <pc:sldMk cId="0" sldId="2147479565"/>
-            <ac:spMk id="31" creationId="{9E3A8CEC-9716-0C88-BF23-ADCC8F7A0791}"/>
-          </ac:spMkLst>
-        </pc:spChg>
-        <pc:spChg chg="mod">
-          <ac:chgData name="Clover Sin I Chang (Stinson Communications Inc)" userId="73b31ea9-7b99-4cbb-9f95-6d9e36522bc0" providerId="ADAL" clId="{9ACEEF60-B8C4-4D3A-B0A8-7FADAC6D59DB}" dt="2026-09-01T15:10:34.852" v="171" actId="962"/>
-          <ac:spMkLst>
-            <pc:docMk/>
-            <pc:sldMk cId="0" sldId="2147479565"/>
-            <ac:spMk id="32" creationId="{EA8DFC6F-AF93-4E95-428F-173F4BE0CA0B}"/>
-          </ac:spMkLst>
-        </pc:spChg>
-        <pc:cxnChg chg="ord">
-          <ac:chgData name="Clover Sin I Chang (Stinson Communications Inc)" userId="73b31ea9-7b99-4cbb-9f95-6d9e36522bc0" providerId="ADAL" clId="{9ACEEF60-B8C4-4D3A-B0A8-7FADAC6D59DB}" dt="2026-09-01T15:14:19.255" v="229" actId="13244"/>
-          <ac:cxnSpMkLst>
-            <pc:docMk/>
-            <pc:sldMk cId="0" sldId="2147479565"/>
-            <ac:cxnSpMk id="33" creationId="{6CF6C62B-14C4-C442-CB60-5FCA34CDC97F}"/>
-          </ac:cxnSpMkLst>
-        </pc:cxnChg>
-      </pc:sldChg>
-      <pc:sldChg chg="modSp add mod">
-        <pc:chgData name="Clover Sin I Chang (Stinson Communications Inc)" userId="73b31ea9-7b99-4cbb-9f95-6d9e36522bc0" providerId="ADAL" clId="{9ACEEF60-B8C4-4D3A-B0A8-7FADAC6D59DB}" dt="2026-09-01T15:15:06.300" v="247" actId="13244"/>
-        <pc:sldMkLst>
-          <pc:docMk/>
-          <pc:sldMk cId="0" sldId="2147479566"/>
-        </pc:sldMkLst>
-        <pc:spChg chg="mod">
-          <ac:chgData name="Clover Sin I Chang (Stinson Communications Inc)" userId="73b31ea9-7b99-4cbb-9f95-6d9e36522bc0" providerId="ADAL" clId="{9ACEEF60-B8C4-4D3A-B0A8-7FADAC6D59DB}" dt="2026-09-01T15:10:35.779" v="172" actId="962"/>
-          <ac:spMkLst>
-            <pc:docMk/>
-            <pc:sldMk cId="0" sldId="2147479566"/>
-            <ac:spMk id="6" creationId="{33E3DE00-A381-D339-0F7C-3E8FAA524C4D}"/>
-          </ac:spMkLst>
-        </pc:spChg>
-        <pc:spChg chg="mod">
-          <ac:chgData name="Clover Sin I Chang (Stinson Communications Inc)" userId="73b31ea9-7b99-4cbb-9f95-6d9e36522bc0" providerId="ADAL" clId="{9ACEEF60-B8C4-4D3A-B0A8-7FADAC6D59DB}" dt="2026-09-01T15:10:36.327" v="173" actId="962"/>
-          <ac:spMkLst>
-            <pc:docMk/>
-            <pc:sldMk cId="0" sldId="2147479566"/>
-            <ac:spMk id="35" creationId="{03519318-856F-003E-F62F-89B7420E9215}"/>
-          </ac:spMkLst>
-        </pc:spChg>
-        <pc:spChg chg="mod">
-          <ac:chgData name="Clover Sin I Chang (Stinson Communications Inc)" userId="73b31ea9-7b99-4cbb-9f95-6d9e36522bc0" providerId="ADAL" clId="{9ACEEF60-B8C4-4D3A-B0A8-7FADAC6D59DB}" dt="2026-09-01T15:10:36.916" v="174" actId="962"/>
-          <ac:spMkLst>
-            <pc:docMk/>
-            <pc:sldMk cId="0" sldId="2147479566"/>
-            <ac:spMk id="36" creationId="{A0544DEE-AFEF-A96B-1755-ACE6012A2E12}"/>
-          </ac:spMkLst>
-        </pc:spChg>
-        <pc:spChg chg="mod">
-          <ac:chgData name="Clover Sin I Chang (Stinson Communications Inc)" userId="73b31ea9-7b99-4cbb-9f95-6d9e36522bc0" providerId="ADAL" clId="{9ACEEF60-B8C4-4D3A-B0A8-7FADAC6D59DB}" dt="2026-09-01T15:10:37.497" v="175" actId="962"/>
-          <ac:spMkLst>
-            <pc:docMk/>
-            <pc:sldMk cId="0" sldId="2147479566"/>
-            <ac:spMk id="37" creationId="{BD77872E-A305-E852-E14D-6F7BE82D2471}"/>
-          </ac:spMkLst>
-        </pc:spChg>
-        <pc:spChg chg="mod">
-          <ac:chgData name="Clover Sin I Chang (Stinson Communications Inc)" userId="73b31ea9-7b99-4cbb-9f95-6d9e36522bc0" providerId="ADAL" clId="{9ACEEF60-B8C4-4D3A-B0A8-7FADAC6D59DB}" dt="2026-09-01T15:10:38.030" v="176" actId="962"/>
-          <ac:spMkLst>
-            <pc:docMk/>
-            <pc:sldMk cId="0" sldId="2147479566"/>
-            <ac:spMk id="38" creationId="{27D754B9-E1CD-D7B6-BB27-4F3BE91FA412}"/>
-          </ac:spMkLst>
-        </pc:spChg>
-        <pc:spChg chg="ord">
-          <ac:chgData name="Clover Sin I Chang (Stinson Communications Inc)" userId="73b31ea9-7b99-4cbb-9f95-6d9e36522bc0" providerId="ADAL" clId="{9ACEEF60-B8C4-4D3A-B0A8-7FADAC6D59DB}" dt="2026-09-01T15:14:30.028" v="231" actId="13244"/>
-          <ac:spMkLst>
-            <pc:docMk/>
-            <pc:sldMk cId="0" sldId="2147479566"/>
-            <ac:spMk id="39" creationId="{CBBDDC27-693D-0705-73F7-0580838A8C31}"/>
-          </ac:spMkLst>
-        </pc:spChg>
-        <pc:spChg chg="ord">
-          <ac:chgData name="Clover Sin I Chang (Stinson Communications Inc)" userId="73b31ea9-7b99-4cbb-9f95-6d9e36522bc0" providerId="ADAL" clId="{9ACEEF60-B8C4-4D3A-B0A8-7FADAC6D59DB}" dt="2026-09-01T15:14:31.425" v="232" actId="13244"/>
-          <ac:spMkLst>
-            <pc:docMk/>
-            <pc:sldMk cId="0" sldId="2147479566"/>
-            <ac:spMk id="40" creationId="{18007830-658E-4AF1-F9C5-285AA5AC749A}"/>
-          </ac:spMkLst>
-        </pc:spChg>
-        <pc:spChg chg="ord">
-          <ac:chgData name="Clover Sin I Chang (Stinson Communications Inc)" userId="73b31ea9-7b99-4cbb-9f95-6d9e36522bc0" providerId="ADAL" clId="{9ACEEF60-B8C4-4D3A-B0A8-7FADAC6D59DB}" dt="2026-09-01T15:14:34.436" v="233" actId="13244"/>
-          <ac:spMkLst>
-            <pc:docMk/>
-            <pc:sldMk cId="0" sldId="2147479566"/>
-            <ac:spMk id="41" creationId="{E5D353B6-7919-98F3-979D-2BDAF63E2DB5}"/>
-          </ac:spMkLst>
-        </pc:spChg>
-        <pc:spChg chg="ord">
-          <ac:chgData name="Clover Sin I Chang (Stinson Communications Inc)" userId="73b31ea9-7b99-4cbb-9f95-6d9e36522bc0" providerId="ADAL" clId="{9ACEEF60-B8C4-4D3A-B0A8-7FADAC6D59DB}" dt="2026-09-01T15:14:35.579" v="234" actId="13244"/>
-          <ac:spMkLst>
-            <pc:docMk/>
-            <pc:sldMk cId="0" sldId="2147479566"/>
-            <ac:spMk id="42" creationId="{ED9031C7-64B7-A1F4-5AA5-CA9B80A250DD}"/>
-          </ac:spMkLst>
-        </pc:spChg>
-        <pc:spChg chg="ord">
-          <ac:chgData name="Clover Sin I Chang (Stinson Communications Inc)" userId="73b31ea9-7b99-4cbb-9f95-6d9e36522bc0" providerId="ADAL" clId="{9ACEEF60-B8C4-4D3A-B0A8-7FADAC6D59DB}" dt="2026-09-01T15:14:37.524" v="235" actId="13244"/>
-          <ac:spMkLst>
-            <pc:docMk/>
-            <pc:sldMk cId="0" sldId="2147479566"/>
-            <ac:spMk id="43" creationId="{69869611-83F1-C416-78DF-D172001DB517}"/>
-          </ac:spMkLst>
-        </pc:spChg>
-        <pc:spChg chg="ord">
-          <ac:chgData name="Clover Sin I Chang (Stinson Communications Inc)" userId="73b31ea9-7b99-4cbb-9f95-6d9e36522bc0" providerId="ADAL" clId="{9ACEEF60-B8C4-4D3A-B0A8-7FADAC6D59DB}" dt="2026-09-01T15:14:38.548" v="236" actId="13244"/>
-          <ac:spMkLst>
-            <pc:docMk/>
-            <pc:sldMk cId="0" sldId="2147479566"/>
-            <ac:spMk id="44" creationId="{543B5D2C-4DB6-AE4F-4A5D-B377C7B88773}"/>
-          </ac:spMkLst>
-        </pc:spChg>
-        <pc:spChg chg="ord">
-          <ac:chgData name="Clover Sin I Chang (Stinson Communications Inc)" userId="73b31ea9-7b99-4cbb-9f95-6d9e36522bc0" providerId="ADAL" clId="{9ACEEF60-B8C4-4D3A-B0A8-7FADAC6D59DB}" dt="2026-09-01T15:14:40.116" v="237" actId="13244"/>
-          <ac:spMkLst>
-            <pc:docMk/>
-            <pc:sldMk cId="0" sldId="2147479566"/>
-            <ac:spMk id="45" creationId="{2E64E1B3-ACDE-1C82-C5D3-DB37BE3EBC91}"/>
-          </ac:spMkLst>
-        </pc:spChg>
-        <pc:spChg chg="ord">
-          <ac:chgData name="Clover Sin I Chang (Stinson Communications Inc)" userId="73b31ea9-7b99-4cbb-9f95-6d9e36522bc0" providerId="ADAL" clId="{9ACEEF60-B8C4-4D3A-B0A8-7FADAC6D59DB}" dt="2026-09-01T15:14:40.921" v="238" actId="13244"/>
-          <ac:spMkLst>
-            <pc:docMk/>
-            <pc:sldMk cId="0" sldId="2147479566"/>
-            <ac:spMk id="46" creationId="{4B6B024D-819D-7F17-D0FF-581C1547ED82}"/>
-          </ac:spMkLst>
-        </pc:spChg>
-        <pc:spChg chg="ord">
-          <ac:chgData name="Clover Sin I Chang (Stinson Communications Inc)" userId="73b31ea9-7b99-4cbb-9f95-6d9e36522bc0" providerId="ADAL" clId="{9ACEEF60-B8C4-4D3A-B0A8-7FADAC6D59DB}" dt="2026-09-01T15:14:44.215" v="239" actId="13244"/>
-          <ac:spMkLst>
-            <pc:docMk/>
-            <pc:sldMk cId="0" sldId="2147479566"/>
-            <ac:spMk id="49" creationId="{00192975-D9E1-CFA0-597E-3F84AA562E29}"/>
-          </ac:spMkLst>
-        </pc:spChg>
-        <pc:spChg chg="ord">
-          <ac:chgData name="Clover Sin I Chang (Stinson Communications Inc)" userId="73b31ea9-7b99-4cbb-9f95-6d9e36522bc0" providerId="ADAL" clId="{9ACEEF60-B8C4-4D3A-B0A8-7FADAC6D59DB}" dt="2026-09-01T15:14:49.589" v="240" actId="13244"/>
-          <ac:spMkLst>
-            <pc:docMk/>
-            <pc:sldMk cId="0" sldId="2147479566"/>
-            <ac:spMk id="50" creationId="{C00FCF96-0C9E-91F3-2581-8BD7BE1D814E}"/>
-          </ac:spMkLst>
-        </pc:spChg>
-        <pc:spChg chg="ord">
-          <ac:chgData name="Clover Sin I Chang (Stinson Communications Inc)" userId="73b31ea9-7b99-4cbb-9f95-6d9e36522bc0" providerId="ADAL" clId="{9ACEEF60-B8C4-4D3A-B0A8-7FADAC6D59DB}" dt="2026-09-01T15:14:51.433" v="241" actId="13244"/>
-          <ac:spMkLst>
-            <pc:docMk/>
-            <pc:sldMk cId="0" sldId="2147479566"/>
-            <ac:spMk id="51" creationId="{90BD235D-9AF9-ABC5-4C91-631B09356744}"/>
-          </ac:spMkLst>
-        </pc:spChg>
-        <pc:spChg chg="ord">
-          <ac:chgData name="Clover Sin I Chang (Stinson Communications Inc)" userId="73b31ea9-7b99-4cbb-9f95-6d9e36522bc0" providerId="ADAL" clId="{9ACEEF60-B8C4-4D3A-B0A8-7FADAC6D59DB}" dt="2026-09-01T15:14:52.663" v="242" actId="13244"/>
-          <ac:spMkLst>
-            <pc:docMk/>
-            <pc:sldMk cId="0" sldId="2147479566"/>
-            <ac:spMk id="52" creationId="{D0BDAEBD-ADF0-0A5D-D736-6D84EDDC6625}"/>
-          </ac:spMkLst>
-        </pc:spChg>
-        <pc:spChg chg="ord">
-          <ac:chgData name="Clover Sin I Chang (Stinson Communications Inc)" userId="73b31ea9-7b99-4cbb-9f95-6d9e36522bc0" providerId="ADAL" clId="{9ACEEF60-B8C4-4D3A-B0A8-7FADAC6D59DB}" dt="2026-09-01T15:14:55.243" v="243" actId="13244"/>
-          <ac:spMkLst>
-            <pc:docMk/>
-            <pc:sldMk cId="0" sldId="2147479566"/>
-            <ac:spMk id="53" creationId="{BA95BC22-4308-5D4A-9EFF-12AB10A1602F}"/>
-          </ac:spMkLst>
-        </pc:spChg>
-        <pc:spChg chg="ord">
-          <ac:chgData name="Clover Sin I Chang (Stinson Communications Inc)" userId="73b31ea9-7b99-4cbb-9f95-6d9e36522bc0" providerId="ADAL" clId="{9ACEEF60-B8C4-4D3A-B0A8-7FADAC6D59DB}" dt="2026-09-01T15:14:24.060" v="230" actId="13244"/>
-          <ac:spMkLst>
-            <pc:docMk/>
-            <pc:sldMk cId="0" sldId="2147479566"/>
-            <ac:spMk id="59" creationId="{9F9765E3-2823-BFC2-FDEE-4ADE8C74EB55}"/>
-          </ac:spMkLst>
-        </pc:spChg>
-        <pc:cxnChg chg="ord">
-          <ac:chgData name="Clover Sin I Chang (Stinson Communications Inc)" userId="73b31ea9-7b99-4cbb-9f95-6d9e36522bc0" providerId="ADAL" clId="{9ACEEF60-B8C4-4D3A-B0A8-7FADAC6D59DB}" dt="2026-09-01T15:15:01.282" v="244" actId="13244"/>
-          <ac:cxnSpMkLst>
-            <pc:docMk/>
-            <pc:sldMk cId="0" sldId="2147479566"/>
-            <ac:cxnSpMk id="54" creationId="{9483AE46-5309-6DE8-4856-BA51875CA452}"/>
-          </ac:cxnSpMkLst>
-        </pc:cxnChg>
-        <pc:cxnChg chg="ord">
-          <ac:chgData name="Clover Sin I Chang (Stinson Communications Inc)" userId="73b31ea9-7b99-4cbb-9f95-6d9e36522bc0" providerId="ADAL" clId="{9ACEEF60-B8C4-4D3A-B0A8-7FADAC6D59DB}" dt="2026-09-01T15:15:03.318" v="245" actId="13244"/>
-          <ac:cxnSpMkLst>
-            <pc:docMk/>
-            <pc:sldMk cId="0" sldId="2147479566"/>
-            <ac:cxnSpMk id="55" creationId="{80D459E7-544E-F3E5-581E-7283FECB66E1}"/>
-          </ac:cxnSpMkLst>
-        </pc:cxnChg>
-        <pc:cxnChg chg="ord">
-          <ac:chgData name="Clover Sin I Chang (Stinson Communications Inc)" userId="73b31ea9-7b99-4cbb-9f95-6d9e36522bc0" providerId="ADAL" clId="{9ACEEF60-B8C4-4D3A-B0A8-7FADAC6D59DB}" dt="2026-09-01T15:15:04.855" v="246" actId="13244"/>
-          <ac:cxnSpMkLst>
-            <pc:docMk/>
-            <pc:sldMk cId="0" sldId="2147479566"/>
-            <ac:cxnSpMk id="56" creationId="{8121CC0B-A0C7-4151-6495-D06079975CA4}"/>
-          </ac:cxnSpMkLst>
-        </pc:cxnChg>
-        <pc:cxnChg chg="ord">
-          <ac:chgData name="Clover Sin I Chang (Stinson Communications Inc)" userId="73b31ea9-7b99-4cbb-9f95-6d9e36522bc0" providerId="ADAL" clId="{9ACEEF60-B8C4-4D3A-B0A8-7FADAC6D59DB}" dt="2026-09-01T15:15:06.300" v="247" actId="13244"/>
-          <ac:cxnSpMkLst>
-            <pc:docMk/>
-            <pc:sldMk cId="0" sldId="2147479566"/>
-            <ac:cxnSpMk id="57" creationId="{4A10FD8C-139B-C299-42CB-24F485681E16}"/>
-          </ac:cxnSpMkLst>
-        </pc:cxnChg>
-      </pc:sldChg>
-      <pc:sldChg chg="modSp add mod">
-        <pc:chgData name="Clover Sin I Chang (Stinson Communications Inc)" userId="73b31ea9-7b99-4cbb-9f95-6d9e36522bc0" providerId="ADAL" clId="{9ACEEF60-B8C4-4D3A-B0A8-7FADAC6D59DB}" dt="2026-09-01T15:15:22.297" v="250" actId="13244"/>
-        <pc:sldMkLst>
-          <pc:docMk/>
-          <pc:sldMk cId="3033634995" sldId="2147479567"/>
-        </pc:sldMkLst>
-        <pc:spChg chg="ord">
-          <ac:chgData name="Clover Sin I Chang (Stinson Communications Inc)" userId="73b31ea9-7b99-4cbb-9f95-6d9e36522bc0" providerId="ADAL" clId="{9ACEEF60-B8C4-4D3A-B0A8-7FADAC6D59DB}" dt="2026-09-01T15:15:18.103" v="248" actId="13244"/>
-          <ac:spMkLst>
-            <pc:docMk/>
-            <pc:sldMk cId="3033634995" sldId="2147479567"/>
-            <ac:spMk id="3" creationId="{ABD5693B-CC72-2259-806E-A6150C1549E8}"/>
-          </ac:spMkLst>
-        </pc:spChg>
-        <pc:spChg chg="ord">
-          <ac:chgData name="Clover Sin I Chang (Stinson Communications Inc)" userId="73b31ea9-7b99-4cbb-9f95-6d9e36522bc0" providerId="ADAL" clId="{9ACEEF60-B8C4-4D3A-B0A8-7FADAC6D59DB}" dt="2026-09-01T15:15:20.487" v="249" actId="13244"/>
-          <ac:spMkLst>
-            <pc:docMk/>
-            <pc:sldMk cId="3033634995" sldId="2147479567"/>
-            <ac:spMk id="5" creationId="{10B9DCE2-3409-B7EA-E88F-F14A4CF12E56}"/>
-          </ac:spMkLst>
-        </pc:spChg>
-        <pc:picChg chg="mod">
-          <ac:chgData name="Clover Sin I Chang (Stinson Communications Inc)" userId="73b31ea9-7b99-4cbb-9f95-6d9e36522bc0" providerId="ADAL" clId="{9ACEEF60-B8C4-4D3A-B0A8-7FADAC6D59DB}" dt="2026-09-01T15:10:39.008" v="177" actId="962"/>
-          <ac:picMkLst>
-            <pc:docMk/>
-            <pc:sldMk cId="3033634995" sldId="2147479567"/>
-            <ac:picMk id="11" creationId="{75340C87-771F-4F06-8AF2-C073CF9B7D95}"/>
-          </ac:picMkLst>
-        </pc:picChg>
-        <pc:picChg chg="mod">
-          <ac:chgData name="Clover Sin I Chang (Stinson Communications Inc)" userId="73b31ea9-7b99-4cbb-9f95-6d9e36522bc0" providerId="ADAL" clId="{9ACEEF60-B8C4-4D3A-B0A8-7FADAC6D59DB}" dt="2026-09-01T15:10:39.504" v="178" actId="962"/>
-          <ac:picMkLst>
-            <pc:docMk/>
-            <pc:sldMk cId="3033634995" sldId="2147479567"/>
-            <ac:picMk id="13" creationId="{3E45D60F-E838-A50C-4DF9-5D2FA8C062F4}"/>
-          </ac:picMkLst>
-        </pc:picChg>
-        <pc:picChg chg="mod">
-          <ac:chgData name="Clover Sin I Chang (Stinson Communications Inc)" userId="73b31ea9-7b99-4cbb-9f95-6d9e36522bc0" providerId="ADAL" clId="{9ACEEF60-B8C4-4D3A-B0A8-7FADAC6D59DB}" dt="2026-09-01T15:10:40.146" v="179" actId="962"/>
-          <ac:picMkLst>
-            <pc:docMk/>
-            <pc:sldMk cId="3033634995" sldId="2147479567"/>
-            <ac:picMk id="15" creationId="{45D95F62-3F1D-D994-FBF9-5DD31BF0FC4A}"/>
-          </ac:picMkLst>
-        </pc:picChg>
-        <pc:cxnChg chg="ord">
-          <ac:chgData name="Clover Sin I Chang (Stinson Communications Inc)" userId="73b31ea9-7b99-4cbb-9f95-6d9e36522bc0" providerId="ADAL" clId="{9ACEEF60-B8C4-4D3A-B0A8-7FADAC6D59DB}" dt="2026-09-01T15:15:22.297" v="250" actId="13244"/>
-          <ac:cxnSpMkLst>
-            <pc:docMk/>
-            <pc:sldMk cId="3033634995" sldId="2147479567"/>
-            <ac:cxnSpMk id="6" creationId="{AC5A6D78-C70F-2768-DAD3-9E9FDE36058D}"/>
-          </ac:cxnSpMkLst>
-        </pc:cxnChg>
-      </pc:sldChg>
-      <pc:sldChg chg="modSp add mod">
-        <pc:chgData name="Clover Sin I Chang (Stinson Communications Inc)" userId="73b31ea9-7b99-4cbb-9f95-6d9e36522bc0" providerId="ADAL" clId="{9ACEEF60-B8C4-4D3A-B0A8-7FADAC6D59DB}" dt="2026-09-01T15:17:54.295" v="286" actId="1035"/>
-        <pc:sldMkLst>
-          <pc:docMk/>
-          <pc:sldMk cId="0" sldId="2147479568"/>
-        </pc:sldMkLst>
-        <pc:spChg chg="mod">
-          <ac:chgData name="Clover Sin I Chang (Stinson Communications Inc)" userId="73b31ea9-7b99-4cbb-9f95-6d9e36522bc0" providerId="ADAL" clId="{9ACEEF60-B8C4-4D3A-B0A8-7FADAC6D59DB}" dt="2026-09-01T15:17:54.295" v="286" actId="1035"/>
-          <ac:spMkLst>
-            <pc:docMk/>
-            <pc:sldMk cId="0" sldId="2147479568"/>
-            <ac:spMk id="2" creationId="{2379DAA1-8FA2-E707-6453-25651011B974}"/>
-          </ac:spMkLst>
-        </pc:spChg>
-        <pc:spChg chg="mod">
-          <ac:chgData name="Clover Sin I Chang (Stinson Communications Inc)" userId="73b31ea9-7b99-4cbb-9f95-6d9e36522bc0" providerId="ADAL" clId="{9ACEEF60-B8C4-4D3A-B0A8-7FADAC6D59DB}" dt="2026-09-01T15:10:41.561" v="180" actId="962"/>
-          <ac:spMkLst>
-            <pc:docMk/>
-            <pc:sldMk cId="0" sldId="2147479568"/>
-            <ac:spMk id="6" creationId="{DE5DAF62-E273-35DF-2585-1F95048562B1}"/>
-          </ac:spMkLst>
-        </pc:spChg>
-        <pc:spChg chg="ord">
-          <ac:chgData name="Clover Sin I Chang (Stinson Communications Inc)" userId="73b31ea9-7b99-4cbb-9f95-6d9e36522bc0" providerId="ADAL" clId="{9ACEEF60-B8C4-4D3A-B0A8-7FADAC6D59DB}" dt="2026-09-01T15:15:33.294" v="251" actId="13244"/>
-          <ac:spMkLst>
-            <pc:docMk/>
-            <pc:sldMk cId="0" sldId="2147479568"/>
-            <ac:spMk id="22" creationId="{00000000-0000-0000-0000-000000000000}"/>
-          </ac:spMkLst>
-        </pc:spChg>
-        <pc:spChg chg="mod">
-          <ac:chgData name="Clover Sin I Chang (Stinson Communications Inc)" userId="73b31ea9-7b99-4cbb-9f95-6d9e36522bc0" providerId="ADAL" clId="{9ACEEF60-B8C4-4D3A-B0A8-7FADAC6D59DB}" dt="2026-09-01T15:10:42.057" v="181" actId="962"/>
-          <ac:spMkLst>
-            <pc:docMk/>
-            <pc:sldMk cId="0" sldId="2147479568"/>
-            <ac:spMk id="23" creationId="{B2B1892D-4716-29EC-35B1-8ED538CA6CE2}"/>
-          </ac:spMkLst>
-        </pc:spChg>
-        <pc:spChg chg="mod ord">
-          <ac:chgData name="Clover Sin I Chang (Stinson Communications Inc)" userId="73b31ea9-7b99-4cbb-9f95-6d9e36522bc0" providerId="ADAL" clId="{9ACEEF60-B8C4-4D3A-B0A8-7FADAC6D59DB}" dt="2026-09-01T15:17:47.765" v="283" actId="13244"/>
-          <ac:spMkLst>
-            <pc:docMk/>
-            <pc:sldMk cId="0" sldId="2147479568"/>
-            <ac:spMk id="24" creationId="{1B4DC662-D8A0-B1A1-FE62-BD307372293D}"/>
-          </ac:spMkLst>
-        </pc:spChg>
-        <pc:spChg chg="ord">
-          <ac:chgData name="Clover Sin I Chang (Stinson Communications Inc)" userId="73b31ea9-7b99-4cbb-9f95-6d9e36522bc0" providerId="ADAL" clId="{9ACEEF60-B8C4-4D3A-B0A8-7FADAC6D59DB}" dt="2026-09-01T15:17:04.317" v="274"/>
-          <ac:spMkLst>
-            <pc:docMk/>
-            <pc:sldMk cId="0" sldId="2147479568"/>
-            <ac:spMk id="25" creationId="{2888B649-FB49-975E-766C-D80AE7AAEDDD}"/>
-          </ac:spMkLst>
-        </pc:spChg>
-        <pc:spChg chg="ord">
-          <ac:chgData name="Clover Sin I Chang (Stinson Communications Inc)" userId="73b31ea9-7b99-4cbb-9f95-6d9e36522bc0" providerId="ADAL" clId="{9ACEEF60-B8C4-4D3A-B0A8-7FADAC6D59DB}" dt="2026-09-01T15:17:04.317" v="274"/>
-          <ac:spMkLst>
-            <pc:docMk/>
-            <pc:sldMk cId="0" sldId="2147479568"/>
-            <ac:spMk id="26" creationId="{8881D346-AB63-1E2B-1FF6-B6366399AA1D}"/>
-          </ac:spMkLst>
-        </pc:spChg>
-        <pc:spChg chg="ord">
-          <ac:chgData name="Clover Sin I Chang (Stinson Communications Inc)" userId="73b31ea9-7b99-4cbb-9f95-6d9e36522bc0" providerId="ADAL" clId="{9ACEEF60-B8C4-4D3A-B0A8-7FADAC6D59DB}" dt="2026-09-01T15:17:38.703" v="281"/>
-          <ac:spMkLst>
-            <pc:docMk/>
-            <pc:sldMk cId="0" sldId="2147479568"/>
-            <ac:spMk id="27" creationId="{A3C7F7A2-E284-B3A2-640A-7B0CC2FD0B90}"/>
-          </ac:spMkLst>
-        </pc:spChg>
-        <pc:spChg chg="ord">
-          <ac:chgData name="Clover Sin I Chang (Stinson Communications Inc)" userId="73b31ea9-7b99-4cbb-9f95-6d9e36522bc0" providerId="ADAL" clId="{9ACEEF60-B8C4-4D3A-B0A8-7FADAC6D59DB}" dt="2026-09-01T15:17:38.703" v="281"/>
-          <ac:spMkLst>
-            <pc:docMk/>
-            <pc:sldMk cId="0" sldId="2147479568"/>
-            <ac:spMk id="28" creationId="{A2F21A6F-ED00-E089-B6E9-6FC75CE9252B}"/>
-          </ac:spMkLst>
-        </pc:spChg>
-        <pc:spChg chg="ord">
-          <ac:chgData name="Clover Sin I Chang (Stinson Communications Inc)" userId="73b31ea9-7b99-4cbb-9f95-6d9e36522bc0" providerId="ADAL" clId="{9ACEEF60-B8C4-4D3A-B0A8-7FADAC6D59DB}" dt="2026-09-01T15:16:40.765" v="254" actId="13244"/>
-          <ac:spMkLst>
-            <pc:docMk/>
-            <pc:sldMk cId="0" sldId="2147479568"/>
-            <ac:spMk id="29" creationId="{A236F8BA-3D00-A240-326E-FCC4FB2FDB05}"/>
-          </ac:spMkLst>
-        </pc:spChg>
-        <pc:spChg chg="ord">
-          <ac:chgData name="Clover Sin I Chang (Stinson Communications Inc)" userId="73b31ea9-7b99-4cbb-9f95-6d9e36522bc0" providerId="ADAL" clId="{9ACEEF60-B8C4-4D3A-B0A8-7FADAC6D59DB}" dt="2026-09-01T15:16:42.336" v="255" actId="13244"/>
-          <ac:spMkLst>
-            <pc:docMk/>
-            <pc:sldMk cId="0" sldId="2147479568"/>
-            <ac:spMk id="30" creationId="{CA0058AC-ECE0-84BB-5C87-6AFA16CB6D02}"/>
-          </ac:spMkLst>
-        </pc:spChg>
-        <pc:spChg chg="ord">
-          <ac:chgData name="Clover Sin I Chang (Stinson Communications Inc)" userId="73b31ea9-7b99-4cbb-9f95-6d9e36522bc0" providerId="ADAL" clId="{9ACEEF60-B8C4-4D3A-B0A8-7FADAC6D59DB}" dt="2026-09-01T15:17:48.954" v="284" actId="13244"/>
-          <ac:spMkLst>
-            <pc:docMk/>
-            <pc:sldMk cId="0" sldId="2147479568"/>
-            <ac:spMk id="32" creationId="{33B1CBA5-DCBD-0695-44CC-F91D49B02098}"/>
-          </ac:spMkLst>
-        </pc:spChg>
-        <pc:spChg chg="ord">
-          <ac:chgData name="Clover Sin I Chang (Stinson Communications Inc)" userId="73b31ea9-7b99-4cbb-9f95-6d9e36522bc0" providerId="ADAL" clId="{9ACEEF60-B8C4-4D3A-B0A8-7FADAC6D59DB}" dt="2026-09-01T15:16:44.392" v="256" actId="13244"/>
-          <ac:spMkLst>
-            <pc:docMk/>
-            <pc:sldMk cId="0" sldId="2147479568"/>
-            <ac:spMk id="35" creationId="{058F91F4-9C6B-016F-C409-83B47A5E7AD0}"/>
-          </ac:spMkLst>
-        </pc:spChg>
-        <pc:spChg chg="ord">
-          <ac:chgData name="Clover Sin I Chang (Stinson Communications Inc)" userId="73b31ea9-7b99-4cbb-9f95-6d9e36522bc0" providerId="ADAL" clId="{9ACEEF60-B8C4-4D3A-B0A8-7FADAC6D59DB}" dt="2026-09-01T15:17:16.067" v="276" actId="13244"/>
-          <ac:spMkLst>
-            <pc:docMk/>
-            <pc:sldMk cId="0" sldId="2147479568"/>
-            <ac:spMk id="38" creationId="{864B0C9E-F7BF-C642-9703-1636B1B70C62}"/>
-          </ac:spMkLst>
-        </pc:spChg>
-        <pc:picChg chg="mod ord">
-          <ac:chgData name="Clover Sin I Chang (Stinson Communications Inc)" userId="73b31ea9-7b99-4cbb-9f95-6d9e36522bc0" providerId="ADAL" clId="{9ACEEF60-B8C4-4D3A-B0A8-7FADAC6D59DB}" dt="2026-09-01T15:17:11.234" v="275" actId="13244"/>
-          <ac:picMkLst>
-            <pc:docMk/>
-            <pc:sldMk cId="0" sldId="2147479568"/>
-            <ac:picMk id="41" creationId="{768DF19D-62EF-DCB1-8D74-3CABD666ADF6}"/>
-          </ac:picMkLst>
-        </pc:picChg>
-        <pc:picChg chg="mod ord">
-          <ac:chgData name="Clover Sin I Chang (Stinson Communications Inc)" userId="73b31ea9-7b99-4cbb-9f95-6d9e36522bc0" providerId="ADAL" clId="{9ACEEF60-B8C4-4D3A-B0A8-7FADAC6D59DB}" dt="2026-09-01T15:17:50.799" v="285" actId="13244"/>
-          <ac:picMkLst>
-            <pc:docMk/>
-            <pc:sldMk cId="0" sldId="2147479568"/>
-            <ac:picMk id="43" creationId="{452D3940-D79B-36E8-3E99-E30921ABAAFA}"/>
-          </ac:picMkLst>
-        </pc:picChg>
-        <pc:picChg chg="mod ord">
-          <ac:chgData name="Clover Sin I Chang (Stinson Communications Inc)" userId="73b31ea9-7b99-4cbb-9f95-6d9e36522bc0" providerId="ADAL" clId="{9ACEEF60-B8C4-4D3A-B0A8-7FADAC6D59DB}" dt="2026-09-01T15:17:26.110" v="277" actId="13244"/>
-          <ac:picMkLst>
-            <pc:docMk/>
-            <pc:sldMk cId="0" sldId="2147479568"/>
-            <ac:picMk id="45" creationId="{508C65EF-186A-45D4-F30A-F6545B7B1AA0}"/>
-          </ac:picMkLst>
-        </pc:picChg>
-      </pc:sldChg>
-      <pc:sldChg chg="modSp add mod">
-        <pc:chgData name="Clover Sin I Chang (Stinson Communications Inc)" userId="73b31ea9-7b99-4cbb-9f95-6d9e36522bc0" providerId="ADAL" clId="{9ACEEF60-B8C4-4D3A-B0A8-7FADAC6D59DB}" dt="2026-09-01T15:18:20.202" v="293" actId="20577"/>
-        <pc:sldMkLst>
-          <pc:docMk/>
-          <pc:sldMk cId="3625117567" sldId="2147479569"/>
-        </pc:sldMkLst>
-        <pc:spChg chg="mod">
-          <ac:chgData name="Clover Sin I Chang (Stinson Communications Inc)" userId="73b31ea9-7b99-4cbb-9f95-6d9e36522bc0" providerId="ADAL" clId="{9ACEEF60-B8C4-4D3A-B0A8-7FADAC6D59DB}" dt="2026-09-01T15:18:20.202" v="293" actId="20577"/>
-          <ac:spMkLst>
-            <pc:docMk/>
-            <pc:sldMk cId="3625117567" sldId="2147479569"/>
-            <ac:spMk id="3" creationId="{0FE0D6F5-26B9-84F6-7E16-446C18B2EAB6}"/>
-          </ac:spMkLst>
-        </pc:spChg>
-        <pc:spChg chg="ord">
-          <ac:chgData name="Clover Sin I Chang (Stinson Communications Inc)" userId="73b31ea9-7b99-4cbb-9f95-6d9e36522bc0" providerId="ADAL" clId="{9ACEEF60-B8C4-4D3A-B0A8-7FADAC6D59DB}" dt="2026-09-01T15:18:09.921" v="289" actId="13244"/>
-          <ac:spMkLst>
-            <pc:docMk/>
-            <pc:sldMk cId="3625117567" sldId="2147479569"/>
-            <ac:spMk id="5" creationId="{FB5093F4-06C0-3C7A-8884-261D19685441}"/>
-          </ac:spMkLst>
-        </pc:spChg>
-        <pc:spChg chg="ord">
-          <ac:chgData name="Clover Sin I Chang (Stinson Communications Inc)" userId="73b31ea9-7b99-4cbb-9f95-6d9e36522bc0" providerId="ADAL" clId="{9ACEEF60-B8C4-4D3A-B0A8-7FADAC6D59DB}" dt="2026-09-01T15:18:12.031" v="290" actId="13244"/>
-          <ac:spMkLst>
-            <pc:docMk/>
-            <pc:sldMk cId="3625117567" sldId="2147479569"/>
-            <ac:spMk id="13" creationId="{EA32C4E1-F16A-19AC-1F03-187AE7E26B6B}"/>
-          </ac:spMkLst>
-        </pc:spChg>
-        <pc:spChg chg="ord">
-          <ac:chgData name="Clover Sin I Chang (Stinson Communications Inc)" userId="73b31ea9-7b99-4cbb-9f95-6d9e36522bc0" providerId="ADAL" clId="{9ACEEF60-B8C4-4D3A-B0A8-7FADAC6D59DB}" dt="2026-09-01T15:18:18.090" v="291" actId="13244"/>
-          <ac:spMkLst>
-            <pc:docMk/>
-            <pc:sldMk cId="3625117567" sldId="2147479569"/>
-            <ac:spMk id="14" creationId="{CD375C19-3AB3-F1A7-B464-7210C4C3C84D}"/>
-          </ac:spMkLst>
-        </pc:spChg>
-        <pc:cxnChg chg="ord">
-          <ac:chgData name="Clover Sin I Chang (Stinson Communications Inc)" userId="73b31ea9-7b99-4cbb-9f95-6d9e36522bc0" providerId="ADAL" clId="{9ACEEF60-B8C4-4D3A-B0A8-7FADAC6D59DB}" dt="2026-09-01T15:18:07.368" v="288" actId="13244"/>
-          <ac:cxnSpMkLst>
-            <pc:docMk/>
-            <pc:sldMk cId="3625117567" sldId="2147479569"/>
-            <ac:cxnSpMk id="7" creationId="{EC4FDEE4-3C5A-E9DA-3A00-62D79BF7B8C7}"/>
-          </ac:cxnSpMkLst>
-        </pc:cxnChg>
-      </pc:sldChg>
-      <pc:sldMasterChg chg="del delSldLayout">
-        <pc:chgData name="Clover Sin I Chang (Stinson Communications Inc)" userId="73b31ea9-7b99-4cbb-9f95-6d9e36522bc0" providerId="ADAL" clId="{9ACEEF60-B8C4-4D3A-B0A8-7FADAC6D59DB}" dt="2026-09-01T15:06:36.742" v="37" actId="47"/>
-        <pc:sldMasterMkLst>
-          <pc:docMk/>
-          <pc:sldMasterMk cId="2209977519" sldId="2147483648"/>
-        </pc:sldMasterMkLst>
-        <pc:sldLayoutChg chg="del">
-          <pc:chgData name="Clover Sin I Chang (Stinson Communications Inc)" userId="73b31ea9-7b99-4cbb-9f95-6d9e36522bc0" providerId="ADAL" clId="{9ACEEF60-B8C4-4D3A-B0A8-7FADAC6D59DB}" dt="2026-09-01T15:06:36.742" v="37" actId="47"/>
-          <pc:sldLayoutMkLst>
-            <pc:docMk/>
-            <pc:sldMasterMk cId="2209977519" sldId="2147483648"/>
-            <pc:sldLayoutMk cId="3168075583" sldId="2147483649"/>
-          </pc:sldLayoutMkLst>
-        </pc:sldLayoutChg>
-        <pc:sldLayoutChg chg="del">
-          <pc:chgData name="Clover Sin I Chang (Stinson Communications Inc)" userId="73b31ea9-7b99-4cbb-9f95-6d9e36522bc0" providerId="ADAL" clId="{9ACEEF60-B8C4-4D3A-B0A8-7FADAC6D59DB}" dt="2026-09-01T15:06:36.742" v="37" actId="47"/>
-          <pc:sldLayoutMkLst>
-            <pc:docMk/>
-            <pc:sldMasterMk cId="2209977519" sldId="2147483648"/>
-            <pc:sldLayoutMk cId="2614314258" sldId="2147483650"/>
-          </pc:sldLayoutMkLst>
-        </pc:sldLayoutChg>
-        <pc:sldLayoutChg chg="del">
-          <pc:chgData name="Clover Sin I Chang (Stinson Communications Inc)" userId="73b31ea9-7b99-4cbb-9f95-6d9e36522bc0" providerId="ADAL" clId="{9ACEEF60-B8C4-4D3A-B0A8-7FADAC6D59DB}" dt="2026-09-01T15:06:36.742" v="37" actId="47"/>
-          <pc:sldLayoutMkLst>
-            <pc:docMk/>
-            <pc:sldMasterMk cId="2209977519" sldId="2147483648"/>
-            <pc:sldLayoutMk cId="960648375" sldId="2147483651"/>
-          </pc:sldLayoutMkLst>
-        </pc:sldLayoutChg>
-        <pc:sldLayoutChg chg="del">
-          <pc:chgData name="Clover Sin I Chang (Stinson Communications Inc)" userId="73b31ea9-7b99-4cbb-9f95-6d9e36522bc0" providerId="ADAL" clId="{9ACEEF60-B8C4-4D3A-B0A8-7FADAC6D59DB}" dt="2026-09-01T15:06:36.742" v="37" actId="47"/>
-          <pc:sldLayoutMkLst>
-            <pc:docMk/>
-            <pc:sldMasterMk cId="2209977519" sldId="2147483648"/>
-            <pc:sldLayoutMk cId="2782244947" sldId="2147483652"/>
-          </pc:sldLayoutMkLst>
-        </pc:sldLayoutChg>
-        <pc:sldLayoutChg chg="del">
-          <pc:chgData name="Clover Sin I Chang (Stinson Communications Inc)" userId="73b31ea9-7b99-4cbb-9f95-6d9e36522bc0" providerId="ADAL" clId="{9ACEEF60-B8C4-4D3A-B0A8-7FADAC6D59DB}" dt="2026-09-01T15:06:36.742" v="37" actId="47"/>
-          <pc:sldLayoutMkLst>
-            <pc:docMk/>
-            <pc:sldMasterMk cId="2209977519" sldId="2147483648"/>
-            <pc:sldLayoutMk cId="990158736" sldId="2147483653"/>
-          </pc:sldLayoutMkLst>
-        </pc:sldLayoutChg>
-        <pc:sldLayoutChg chg="del">
-          <pc:chgData name="Clover Sin I Chang (Stinson Communications Inc)" userId="73b31ea9-7b99-4cbb-9f95-6d9e36522bc0" providerId="ADAL" clId="{9ACEEF60-B8C4-4D3A-B0A8-7FADAC6D59DB}" dt="2026-09-01T15:06:36.742" v="37" actId="47"/>
-          <pc:sldLayoutMkLst>
-            <pc:docMk/>
-            <pc:sldMasterMk cId="2209977519" sldId="2147483648"/>
-            <pc:sldLayoutMk cId="727027711" sldId="2147483654"/>
-          </pc:sldLayoutMkLst>
-        </pc:sldLayoutChg>
-        <pc:sldLayoutChg chg="del">
-          <pc:chgData name="Clover Sin I Chang (Stinson Communications Inc)" userId="73b31ea9-7b99-4cbb-9f95-6d9e36522bc0" providerId="ADAL" clId="{9ACEEF60-B8C4-4D3A-B0A8-7FADAC6D59DB}" dt="2026-09-01T15:06:36.742" v="37" actId="47"/>
-          <pc:sldLayoutMkLst>
-            <pc:docMk/>
-            <pc:sldMasterMk cId="2209977519" sldId="2147483648"/>
-            <pc:sldLayoutMk cId="1212999818" sldId="2147483655"/>
-          </pc:sldLayoutMkLst>
-        </pc:sldLayoutChg>
-        <pc:sldLayoutChg chg="del">
-          <pc:chgData name="Clover Sin I Chang (Stinson Communications Inc)" userId="73b31ea9-7b99-4cbb-9f95-6d9e36522bc0" providerId="ADAL" clId="{9ACEEF60-B8C4-4D3A-B0A8-7FADAC6D59DB}" dt="2026-09-01T15:06:36.742" v="37" actId="47"/>
-          <pc:sldLayoutMkLst>
-            <pc:docMk/>
-            <pc:sldMasterMk cId="2209977519" sldId="2147483648"/>
-            <pc:sldLayoutMk cId="1840726560" sldId="2147483656"/>
-          </pc:sldLayoutMkLst>
-        </pc:sldLayoutChg>
-        <pc:sldLayoutChg chg="del">
-          <pc:chgData name="Clover Sin I Chang (Stinson Communications Inc)" userId="73b31ea9-7b99-4cbb-9f95-6d9e36522bc0" providerId="ADAL" clId="{9ACEEF60-B8C4-4D3A-B0A8-7FADAC6D59DB}" dt="2026-09-01T15:06:36.742" v="37" actId="47"/>
-          <pc:sldLayoutMkLst>
-            <pc:docMk/>
-            <pc:sldMasterMk cId="2209977519" sldId="2147483648"/>
-            <pc:sldLayoutMk cId="3889236939" sldId="2147483657"/>
-          </pc:sldLayoutMkLst>
-        </pc:sldLayoutChg>
-        <pc:sldLayoutChg chg="del">
-          <pc:chgData name="Clover Sin I Chang (Stinson Communications Inc)" userId="73b31ea9-7b99-4cbb-9f95-6d9e36522bc0" providerId="ADAL" clId="{9ACEEF60-B8C4-4D3A-B0A8-7FADAC6D59DB}" dt="2026-09-01T15:06:36.742" v="37" actId="47"/>
-          <pc:sldLayoutMkLst>
-            <pc:docMk/>
-            <pc:sldMasterMk cId="2209977519" sldId="2147483648"/>
-            <pc:sldLayoutMk cId="2910927964" sldId="2147483658"/>
-          </pc:sldLayoutMkLst>
-        </pc:sldLayoutChg>
-        <pc:sldLayoutChg chg="del">
-          <pc:chgData name="Clover Sin I Chang (Stinson Communications Inc)" userId="73b31ea9-7b99-4cbb-9f95-6d9e36522bc0" providerId="ADAL" clId="{9ACEEF60-B8C4-4D3A-B0A8-7FADAC6D59DB}" dt="2026-09-01T15:06:36.742" v="37" actId="47"/>
-          <pc:sldLayoutMkLst>
-            <pc:docMk/>
-            <pc:sldMasterMk cId="2209977519" sldId="2147483648"/>
-            <pc:sldLayoutMk cId="3612223792" sldId="2147483659"/>
-          </pc:sldLayoutMkLst>
-        </pc:sldLayoutChg>
-        <pc:sldLayoutChg chg="del">
-          <pc:chgData name="Clover Sin I Chang (Stinson Communications Inc)" userId="73b31ea9-7b99-4cbb-9f95-6d9e36522bc0" providerId="ADAL" clId="{9ACEEF60-B8C4-4D3A-B0A8-7FADAC6D59DB}" dt="2026-09-01T15:04:15.862" v="5" actId="47"/>
-          <pc:sldLayoutMkLst>
-            <pc:docMk/>
-            <pc:sldMasterMk cId="2209977519" sldId="2147483648"/>
-            <pc:sldLayoutMk cId="1868511134" sldId="2147483660"/>
-          </pc:sldLayoutMkLst>
-        </pc:sldLayoutChg>
-        <pc:sldLayoutChg chg="del">
-          <pc:chgData name="Clover Sin I Chang (Stinson Communications Inc)" userId="73b31ea9-7b99-4cbb-9f95-6d9e36522bc0" providerId="ADAL" clId="{9ACEEF60-B8C4-4D3A-B0A8-7FADAC6D59DB}" dt="2026-09-01T15:04:22.642" v="9" actId="47"/>
-          <pc:sldLayoutMkLst>
-            <pc:docMk/>
-            <pc:sldMasterMk cId="2209977519" sldId="2147483648"/>
-            <pc:sldLayoutMk cId="1377680800" sldId="2147483661"/>
-          </pc:sldLayoutMkLst>
-        </pc:sldLayoutChg>
-        <pc:sldLayoutChg chg="del">
-          <pc:chgData name="Clover Sin I Chang (Stinson Communications Inc)" userId="73b31ea9-7b99-4cbb-9f95-6d9e36522bc0" providerId="ADAL" clId="{9ACEEF60-B8C4-4D3A-B0A8-7FADAC6D59DB}" dt="2026-09-01T15:06:36.742" v="37" actId="47"/>
-          <pc:sldLayoutMkLst>
-            <pc:docMk/>
-            <pc:sldMasterMk cId="2209977519" sldId="2147483648"/>
-            <pc:sldLayoutMk cId="2270066141" sldId="2147483662"/>
-          </pc:sldLayoutMkLst>
-        </pc:sldLayoutChg>
-      </pc:sldMasterChg>
-    </pc:docChg>
-  </pc:docChgLst>
-  <pc:docChgLst>
-    <pc:chgData name="Charles Awe (Stinson Communications Inc)" userId="1444a670-b0cf-41d4-bdc2-8936ddb5019b" providerId="ADAL" clId="{4507BBEB-9F73-4BC3-8BA6-9DFA4678FDC5}"/>
-    <pc:docChg chg="custSel modSld">
-      <pc:chgData name="Charles Awe (Stinson Communications Inc)" userId="1444a670-b0cf-41d4-bdc2-8936ddb5019b" providerId="ADAL" clId="{4507BBEB-9F73-4BC3-8BA6-9DFA4678FDC5}" dt="2026-08-31T18:56:04.269" v="2" actId="14100"/>
-      <pc:docMkLst>
-        <pc:docMk/>
-      </pc:docMkLst>
-      <pc:sldChg chg="addSp delSp modSp mod chgLayout">
-        <pc:chgData name="Charles Awe (Stinson Communications Inc)" userId="1444a670-b0cf-41d4-bdc2-8936ddb5019b" providerId="ADAL" clId="{4507BBEB-9F73-4BC3-8BA6-9DFA4678FDC5}" dt="2026-08-31T18:56:04.269" v="2" actId="14100"/>
-        <pc:sldMkLst>
-          <pc:docMk/>
-          <pc:sldMk cId="143569297" sldId="2147479558"/>
-        </pc:sldMkLst>
-        <pc:spChg chg="mod ord">
-          <ac:chgData name="Charles Awe (Stinson Communications Inc)" userId="1444a670-b0cf-41d4-bdc2-8936ddb5019b" providerId="ADAL" clId="{4507BBEB-9F73-4BC3-8BA6-9DFA4678FDC5}" dt="2026-08-31T18:56:04.269" v="2" actId="14100"/>
-          <ac:spMkLst>
-            <pc:docMk/>
-            <pc:sldMk cId="143569297" sldId="2147479558"/>
-            <ac:spMk id="2" creationId="{9DB265EF-CE90-333A-AE91-4F2DFE26B9A5}"/>
-          </ac:spMkLst>
-        </pc:spChg>
-        <pc:spChg chg="mod ord">
-          <ac:chgData name="Charles Awe (Stinson Communications Inc)" userId="1444a670-b0cf-41d4-bdc2-8936ddb5019b" providerId="ADAL" clId="{4507BBEB-9F73-4BC3-8BA6-9DFA4678FDC5}" dt="2026-08-31T18:55:45.585" v="1" actId="6264"/>
-          <ac:spMkLst>
-            <pc:docMk/>
-            <pc:sldMk cId="143569297" sldId="2147479558"/>
-            <ac:spMk id="3" creationId="{13AA93F6-0237-907D-C0B7-ACABF04C7E9B}"/>
-          </ac:spMkLst>
-        </pc:spChg>
-        <pc:spChg chg="add del mod">
-          <ac:chgData name="Charles Awe (Stinson Communications Inc)" userId="1444a670-b0cf-41d4-bdc2-8936ddb5019b" providerId="ADAL" clId="{4507BBEB-9F73-4BC3-8BA6-9DFA4678FDC5}" dt="2026-08-31T18:55:45.585" v="1" actId="6264"/>
-          <ac:spMkLst>
-            <pc:docMk/>
-            <pc:sldMk cId="143569297" sldId="2147479558"/>
-            <ac:spMk id="4" creationId="{988157F8-F831-CA28-E90E-816BB2F29A2D}"/>
-          </ac:spMkLst>
-        </pc:spChg>
-        <pc:spChg chg="add del mod">
-          <ac:chgData name="Charles Awe (Stinson Communications Inc)" userId="1444a670-b0cf-41d4-bdc2-8936ddb5019b" providerId="ADAL" clId="{4507BBEB-9F73-4BC3-8BA6-9DFA4678FDC5}" dt="2026-08-31T18:55:45.585" v="1" actId="6264"/>
-          <ac:spMkLst>
-            <pc:docMk/>
-            <pc:sldMk cId="143569297" sldId="2147479558"/>
-            <ac:spMk id="5" creationId="{1218DCD8-0470-9C08-63E9-8443CE6BB449}"/>
-          </ac:spMkLst>
-        </pc:spChg>
-      </pc:sldChg>
-    </pc:docChg>
-  </pc:docChgLst>
-</pc:chgInfo>
-</file>
-
 <file path=ppt/notesMasters/notesMaster1.xml><?xml version="1.0" encoding="utf-8"?>
 <p:notesMaster xmlns:a="http://schemas.openxmlformats.org/drawingml/2006/main" xmlns:r="http://schemas.openxmlformats.org/officeDocument/2006/relationships" xmlns:p="http://schemas.openxmlformats.org/presentationml/2006/main">
   <p:cSld>
@@ -1440,7 +218,7 @@
           <a:p>
             <a:fld id="{BF022060-2369-4BE7-AB6D-9267FEBA2BDD}" type="datetimeFigureOut">
               <a:rPr lang="en-US" smtClean="0"/>
-              <a:t>9/1/2026</a:t>
+              <a:t>9/10/2026</a:t>
             </a:fld>
             <a:endParaRPr lang="en-US"/>
           </a:p>
@@ -1751,7 +529,34 @@
           <a:bodyPr/>
           <a:lstStyle/>
           <a:p>
-            <a:endParaRPr lang="en-US" dirty="0"/>
+            <a:r>
+              <a:rPr lang="en-US"/>
+              <a:t>SPEAKER</a:t>
+            </a:r>
+          </a:p>
+          <a:p>
+            <a:r>
+              <a:rPr lang="en-US"/>
+              <a:t>Welcome the room while people settle. Confirm everyone can see the Skillable instructions panel and has their lab credentials. Keep this slide up for no more than 30 seconds.</a:t>
+            </a:r>
+          </a:p>
+          <a:p>
+            <a:r>
+              <a:rPr lang="en-US"/>
+              <a:t>Say: "Welcome to the Microsoft AI Tour. You're in ILL335 - Building and Deploying AI Agents with Microsoft Foundry."</a:t>
+            </a:r>
+          </a:p>
+          <a:p>
+            <a:r>
+              <a:rPr lang="en-US"/>
+              <a:t>ATTENDEE</a:t>
+            </a:r>
+          </a:p>
+          <a:p>
+            <a:r>
+              <a:rPr lang="en-US"/>
+              <a:t>You are in ILL335. This is a hands-on lab: you will write and deploy real code. Open your Skillable instructions panel now and log into the lab VM using the supplied credentials.</a:t>
+            </a:r>
           </a:p>
         </p:txBody>
       </p:sp>
@@ -1770,6 +575,124 @@
           <a:bodyPr/>
           <a:lstStyle/>
           <a:p>
+            <a:fld id="{0EAA6A36-79C2-4EC9-93EE-6F62DDC8ACE2}" type="slidenum">
+              <a:rPr lang="en-US" smtClean="0"/>
+              <a:t>1</a:t>
+            </a:fld>
+            <a:endParaRPr lang="en-US"/>
+          </a:p>
+        </p:txBody>
+      </p:sp>
+    </p:spTree>
+    <p:extLst>
+      <p:ext uri="{BB962C8B-B14F-4D97-AF65-F5344CB8AC3E}">
+        <p14:creationId xmlns:p14="http://schemas.microsoft.com/office/powerpoint/2010/main" val="104617466"/>
+      </p:ext>
+    </p:extLst>
+  </p:cSld>
+  <p:clrMapOvr>
+    <a:masterClrMapping/>
+  </p:clrMapOvr>
+</p:notes>
+</file>
+
+<file path=ppt/notesSlides/notesSlide10.xml><?xml version="1.0" encoding="utf-8"?>
+<p:notes xmlns:a="http://schemas.openxmlformats.org/drawingml/2006/main" xmlns:r="http://schemas.openxmlformats.org/officeDocument/2006/relationships" xmlns:p="http://schemas.openxmlformats.org/presentationml/2006/main">
+  <p:cSld>
+    <p:spTree>
+      <p:nvGrpSpPr>
+        <p:cNvPr id="1" name=""/>
+        <p:cNvGrpSpPr/>
+        <p:nvPr/>
+      </p:nvGrpSpPr>
+      <p:grpSpPr>
+        <a:xfrm>
+          <a:off x="0" y="0"/>
+          <a:ext cx="0" cy="0"/>
+          <a:chOff x="0" y="0"/>
+          <a:chExt cx="0" cy="0"/>
+        </a:xfrm>
+      </p:grpSpPr>
+      <p:sp>
+        <p:nvSpPr>
+          <p:cNvPr id="2" name="Slide Image Placeholder 1"/>
+          <p:cNvSpPr>
+            <a:spLocks noGrp="1" noRot="1" noChangeAspect="1"/>
+          </p:cNvSpPr>
+          <p:nvPr>
+            <p:ph type="sldImg"/>
+          </p:nvPr>
+        </p:nvSpPr>
+        <p:spPr/>
+      </p:sp>
+      <p:sp>
+        <p:nvSpPr>
+          <p:cNvPr id="3" name="Notes Placeholder 2"/>
+          <p:cNvSpPr>
+            <a:spLocks noGrp="1"/>
+          </p:cNvSpPr>
+          <p:nvPr>
+            <p:ph type="body" idx="1"/>
+          </p:nvPr>
+        </p:nvSpPr>
+        <p:spPr/>
+        <p:txBody>
+          <a:bodyPr/>
+          <a:lstStyle/>
+          <a:p>
+            <a:r>
+              <a:rPr lang="en-US"/>
+              <a:t>SPEAKER</a:t>
+            </a:r>
+          </a:p>
+          <a:p>
+            <a:r>
+              <a:rPr lang="en-US"/>
+              <a:t>Slow down here. Define the three regulated categories in plain language and state the boundary: the application never determines causality, seriousness, diagnosis, or treatment. It detects and routes - a human decides.</a:t>
+            </a:r>
+          </a:p>
+          <a:p>
+            <a:r>
+              <a:rPr lang="en-US"/>
+              <a:t>Invite a question or two before moving to the close.</a:t>
+            </a:r>
+          </a:p>
+          <a:p>
+            <a:r>
+              <a:rPr lang="en-US"/>
+              <a:t>Timing: ~60 seconds.</a:t>
+            </a:r>
+          </a:p>
+          <a:p>
+            <a:r>
+              <a:rPr lang="en-US"/>
+              <a:t>ATTENDEE</a:t>
+            </a:r>
+          </a:p>
+          <a:p>
+            <a:r>
+              <a:rPr lang="en-US"/>
+              <a:t>Three regulated signals always go to a human: potential adverse event (a symptom or unwanted experience after use), product quality complaint (packaging, integrity, contamination, performance), and medical inquiry (diagnosis, treatment, dosage, or medical guidance). Your app flags and routes them - it never judges causality, seriousness, diagnosis, or treatment.</a:t>
+            </a:r>
+            <a:endParaRPr lang="en-US" dirty="0"/>
+          </a:p>
+        </p:txBody>
+      </p:sp>
+      <p:sp>
+        <p:nvSpPr>
+          <p:cNvPr id="4" name="Slide Number Placeholder 3"/>
+          <p:cNvSpPr>
+            <a:spLocks noGrp="1"/>
+          </p:cNvSpPr>
+          <p:nvPr>
+            <p:ph type="sldNum" sz="quarter" idx="5"/>
+          </p:nvPr>
+        </p:nvSpPr>
+        <p:spPr/>
+        <p:txBody>
+          <a:bodyPr/>
+          <a:lstStyle/>
+          <a:p>
             <a:fld id="{5ED937A9-DDE4-6640-9D78-29FADF5894C3}" type="slidenum">
               <a:rPr lang="en-US" smtClean="0"/>
               <a:t>10</a:t>
@@ -1782,6 +705,1023 @@
     <p:extLst>
       <p:ext uri="{BB962C8B-B14F-4D97-AF65-F5344CB8AC3E}">
         <p14:creationId xmlns:p14="http://schemas.microsoft.com/office/powerpoint/2010/main" val="4236790269"/>
+      </p:ext>
+    </p:extLst>
+  </p:cSld>
+  <p:clrMapOvr>
+    <a:masterClrMapping/>
+  </p:clrMapOvr>
+</p:notes>
+</file>
+
+<file path=ppt/notesSlides/notesSlide11.xml><?xml version="1.0" encoding="utf-8"?>
+<p:notes xmlns:a="http://schemas.openxmlformats.org/drawingml/2006/main" xmlns:r="http://schemas.openxmlformats.org/officeDocument/2006/relationships" xmlns:p="http://schemas.openxmlformats.org/presentationml/2006/main">
+  <p:cSld>
+    <p:spTree>
+      <p:nvGrpSpPr>
+        <p:cNvPr id="1" name=""/>
+        <p:cNvGrpSpPr/>
+        <p:nvPr/>
+      </p:nvGrpSpPr>
+      <p:grpSpPr>
+        <a:xfrm>
+          <a:off x="0" y="0"/>
+          <a:ext cx="0" cy="0"/>
+          <a:chOff x="0" y="0"/>
+          <a:chExt cx="0" cy="0"/>
+        </a:xfrm>
+      </p:grpSpPr>
+      <p:sp>
+        <p:nvSpPr>
+          <p:cNvPr id="2" name="Slide Image Placeholder 1"/>
+          <p:cNvSpPr>
+            <a:spLocks noGrp="1" noRot="1" noChangeAspect="1"/>
+          </p:cNvSpPr>
+          <p:nvPr>
+            <p:ph type="sldImg"/>
+          </p:nvPr>
+        </p:nvSpPr>
+        <p:spPr/>
+      </p:sp>
+      <p:sp>
+        <p:nvSpPr>
+          <p:cNvPr id="3" name="Notes Placeholder 2"/>
+          <p:cNvSpPr>
+            <a:spLocks noGrp="1"/>
+          </p:cNvSpPr>
+          <p:nvPr>
+            <p:ph type="body" idx="1"/>
+          </p:nvPr>
+        </p:nvSpPr>
+        <p:spPr/>
+        <p:txBody>
+          <a:bodyPr/>
+          <a:lstStyle/>
+          <a:p>
+            <a:r>
+              <a:rPr lang="en-US"/>
+              <a:t>SPEAKER</a:t>
+            </a:r>
+          </a:p>
+          <a:p>
+            <a:r>
+              <a:rPr lang="en-US"/>
+              <a:t>Hand off to hands-on time. Tell everyone to open the Foundry Toolkit in VS Code and begin Lab 1; proctors are circulating. Share the resource center and Discord links and mention Lab 5 can be completed later.</a:t>
+            </a:r>
+          </a:p>
+          <a:p>
+            <a:r>
+              <a:rPr lang="en-US"/>
+              <a:t>Timing: ~30 seconds, then start the labs.</a:t>
+            </a:r>
+          </a:p>
+          <a:p>
+            <a:r>
+              <a:rPr lang="en-US"/>
+              <a:t>ATTENDEE</a:t>
+            </a:r>
+          </a:p>
+          <a:p>
+            <a:r>
+              <a:rPr lang="en-US"/>
+              <a:t>Start Lab 1 now from the Foundry Toolkit in VS Code. Resources: aka.ms/aitour27-resource-center. Community and questions after the event: aka.ms/MicrosoftFoundryDiscord-AITour27.</a:t>
+            </a:r>
+          </a:p>
+        </p:txBody>
+      </p:sp>
+      <p:sp>
+        <p:nvSpPr>
+          <p:cNvPr id="4" name="Slide Number Placeholder 3"/>
+          <p:cNvSpPr>
+            <a:spLocks noGrp="1"/>
+          </p:cNvSpPr>
+          <p:nvPr>
+            <p:ph type="sldNum" sz="quarter" idx="5"/>
+          </p:nvPr>
+        </p:nvSpPr>
+        <p:spPr/>
+        <p:txBody>
+          <a:bodyPr/>
+          <a:lstStyle/>
+          <a:p>
+            <a:fld id="{0EAA6A36-79C2-4EC9-93EE-6F62DDC8ACE2}" type="slidenum">
+              <a:rPr lang="en-US" smtClean="0"/>
+              <a:t>11</a:t>
+            </a:fld>
+            <a:endParaRPr lang="en-US"/>
+          </a:p>
+        </p:txBody>
+      </p:sp>
+    </p:spTree>
+    <p:extLst>
+      <p:ext uri="{BB962C8B-B14F-4D97-AF65-F5344CB8AC3E}">
+        <p14:creationId xmlns:p14="http://schemas.microsoft.com/office/powerpoint/2010/main" val="2788003124"/>
+      </p:ext>
+    </p:extLst>
+  </p:cSld>
+  <p:clrMapOvr>
+    <a:masterClrMapping/>
+  </p:clrMapOvr>
+</p:notes>
+</file>
+
+<file path=ppt/notesSlides/notesSlide2.xml><?xml version="1.0" encoding="utf-8"?>
+<p:notes xmlns:a="http://schemas.openxmlformats.org/drawingml/2006/main" xmlns:r="http://schemas.openxmlformats.org/officeDocument/2006/relationships" xmlns:p="http://schemas.openxmlformats.org/presentationml/2006/main">
+  <p:cSld>
+    <p:spTree>
+      <p:nvGrpSpPr>
+        <p:cNvPr id="1" name=""/>
+        <p:cNvGrpSpPr/>
+        <p:nvPr/>
+      </p:nvGrpSpPr>
+      <p:grpSpPr>
+        <a:xfrm>
+          <a:off x="0" y="0"/>
+          <a:ext cx="0" cy="0"/>
+          <a:chOff x="0" y="0"/>
+          <a:chExt cx="0" cy="0"/>
+        </a:xfrm>
+      </p:grpSpPr>
+      <p:sp>
+        <p:nvSpPr>
+          <p:cNvPr id="2" name="Slide Image Placeholder 1"/>
+          <p:cNvSpPr>
+            <a:spLocks noGrp="1" noRot="1" noChangeAspect="1"/>
+          </p:cNvSpPr>
+          <p:nvPr>
+            <p:ph type="sldImg"/>
+          </p:nvPr>
+        </p:nvSpPr>
+        <p:spPr/>
+      </p:sp>
+      <p:sp>
+        <p:nvSpPr>
+          <p:cNvPr id="3" name="Notes Placeholder 2"/>
+          <p:cNvSpPr>
+            <a:spLocks noGrp="1"/>
+          </p:cNvSpPr>
+          <p:nvPr>
+            <p:ph type="body" idx="1"/>
+          </p:nvPr>
+        </p:nvSpPr>
+        <p:spPr/>
+        <p:txBody>
+          <a:bodyPr/>
+          <a:lstStyle/>
+          <a:p>
+            <a:r>
+              <a:rPr lang="en-US"/>
+              <a:t>SPEAKER</a:t>
+            </a:r>
+          </a:p>
+          <a:p>
+            <a:r>
+              <a:rPr lang="en-US"/>
+              <a:t>Set expectations in five minutes, then get people into Lab 1. Frame the session: five short labs, an end-to-end developer workflow, checkpoints along the way. Say that Lab 5 is self-paced and can be finished after the session.</a:t>
+            </a:r>
+          </a:p>
+          <a:p>
+            <a:r>
+              <a:rPr lang="en-US"/>
+              <a:t>Timing: ~30 seconds on this slide.</a:t>
+            </a:r>
+          </a:p>
+          <a:p>
+            <a:r>
+              <a:rPr lang="en-US"/>
+              <a:t>ATTENDEE</a:t>
+            </a:r>
+          </a:p>
+          <a:p>
+            <a:r>
+              <a:rPr lang="en-US"/>
+              <a:t>This short intro covers the scenario, the Foundry concepts you need, and how the live session runs. You will discover a model, verify your project, call it from Python, add governed JSON routing, and deploy a hosted agent.</a:t>
+            </a:r>
+          </a:p>
+        </p:txBody>
+      </p:sp>
+      <p:sp>
+        <p:nvSpPr>
+          <p:cNvPr id="4" name="Slide Number Placeholder 3"/>
+          <p:cNvSpPr>
+            <a:spLocks noGrp="1"/>
+          </p:cNvSpPr>
+          <p:nvPr>
+            <p:ph type="sldNum" sz="quarter" idx="5"/>
+          </p:nvPr>
+        </p:nvSpPr>
+        <p:spPr/>
+        <p:txBody>
+          <a:bodyPr/>
+          <a:lstStyle/>
+          <a:p>
+            <a:fld id="{0EAA6A36-79C2-4EC9-93EE-6F62DDC8ACE2}" type="slidenum">
+              <a:rPr lang="en-US" smtClean="0"/>
+              <a:t>2</a:t>
+            </a:fld>
+            <a:endParaRPr lang="en-US"/>
+          </a:p>
+        </p:txBody>
+      </p:sp>
+    </p:spTree>
+    <p:extLst>
+      <p:ext uri="{BB962C8B-B14F-4D97-AF65-F5344CB8AC3E}">
+        <p14:creationId xmlns:p14="http://schemas.microsoft.com/office/powerpoint/2010/main" val="1841317272"/>
+      </p:ext>
+    </p:extLst>
+  </p:cSld>
+  <p:clrMapOvr>
+    <a:masterClrMapping/>
+  </p:clrMapOvr>
+</p:notes>
+</file>
+
+<file path=ppt/notesSlides/notesSlide3.xml><?xml version="1.0" encoding="utf-8"?>
+<p:notes xmlns:a="http://schemas.openxmlformats.org/drawingml/2006/main" xmlns:r="http://schemas.openxmlformats.org/officeDocument/2006/relationships" xmlns:p="http://schemas.openxmlformats.org/presentationml/2006/main">
+  <p:cSld>
+    <p:spTree>
+      <p:nvGrpSpPr>
+        <p:cNvPr id="1" name=""/>
+        <p:cNvGrpSpPr/>
+        <p:nvPr/>
+      </p:nvGrpSpPr>
+      <p:grpSpPr>
+        <a:xfrm>
+          <a:off x="0" y="0"/>
+          <a:ext cx="0" cy="0"/>
+          <a:chOff x="0" y="0"/>
+          <a:chExt cx="0" cy="0"/>
+        </a:xfrm>
+      </p:grpSpPr>
+      <p:sp>
+        <p:nvSpPr>
+          <p:cNvPr id="2" name="Slide Image Placeholder 1"/>
+          <p:cNvSpPr>
+            <a:spLocks noGrp="1" noRot="1" noChangeAspect="1"/>
+          </p:cNvSpPr>
+          <p:nvPr>
+            <p:ph type="sldImg"/>
+          </p:nvPr>
+        </p:nvSpPr>
+        <p:spPr/>
+      </p:sp>
+      <p:sp>
+        <p:nvSpPr>
+          <p:cNvPr id="3" name="Notes Placeholder 2"/>
+          <p:cNvSpPr>
+            <a:spLocks noGrp="1"/>
+          </p:cNvSpPr>
+          <p:nvPr>
+            <p:ph type="body" idx="1"/>
+          </p:nvPr>
+        </p:nvSpPr>
+        <p:spPr/>
+        <p:txBody>
+          <a:bodyPr/>
+          <a:lstStyle/>
+          <a:p>
+            <a:r>
+              <a:rPr lang="en-US"/>
+              <a:t>SPEAKER</a:t>
+            </a:r>
+          </a:p>
+          <a:p>
+            <a:r>
+              <a:rPr lang="en-US"/>
+              <a:t>Ground the lab in the business problem before any tooling. Caldova is a fictional consumer-health company drowning in feedback across products and support channels. Emphasise the finish line: a managed hosted agent callable through the Responses API.</a:t>
+            </a:r>
+          </a:p>
+          <a:p>
+            <a:r>
+              <a:rPr lang="en-US"/>
+              <a:t>Stress the word "independently" - regulated signals are flagged for a human, never auto-resolved.</a:t>
+            </a:r>
+          </a:p>
+          <a:p>
+            <a:r>
+              <a:rPr lang="en-US"/>
+              <a:t>Timing: ~45 seconds.</a:t>
+            </a:r>
+          </a:p>
+          <a:p>
+            <a:r>
+              <a:rPr lang="en-US"/>
+              <a:t>ATTENDEE</a:t>
+            </a:r>
+          </a:p>
+          <a:p>
+            <a:r>
+              <a:rPr lang="en-US"/>
+              <a:t>Your role: an AI developer at Caldova. Your mission: classify sentiment, summarise topics, and flag regulated signals for human review. Your finish line: a hosted agent running on Foundry's managed runtime that your application can call through the Responses API.</a:t>
+            </a:r>
+          </a:p>
+        </p:txBody>
+      </p:sp>
+      <p:sp>
+        <p:nvSpPr>
+          <p:cNvPr id="4" name="Slide Number Placeholder 3"/>
+          <p:cNvSpPr>
+            <a:spLocks noGrp="1"/>
+          </p:cNvSpPr>
+          <p:nvPr>
+            <p:ph type="sldNum" sz="quarter" idx="5"/>
+          </p:nvPr>
+        </p:nvSpPr>
+        <p:spPr/>
+        <p:txBody>
+          <a:bodyPr/>
+          <a:lstStyle/>
+          <a:p>
+            <a:fld id="{0EAA6A36-79C2-4EC9-93EE-6F62DDC8ACE2}" type="slidenum">
+              <a:rPr lang="en-US" smtClean="0"/>
+              <a:t>3</a:t>
+            </a:fld>
+            <a:endParaRPr lang="en-US"/>
+          </a:p>
+        </p:txBody>
+      </p:sp>
+    </p:spTree>
+    <p:extLst>
+      <p:ext uri="{BB962C8B-B14F-4D97-AF65-F5344CB8AC3E}">
+        <p14:creationId xmlns:p14="http://schemas.microsoft.com/office/powerpoint/2010/main" val="3616818594"/>
+      </p:ext>
+    </p:extLst>
+  </p:cSld>
+  <p:clrMapOvr>
+    <a:masterClrMapping/>
+  </p:clrMapOvr>
+</p:notes>
+</file>
+
+<file path=ppt/notesSlides/notesSlide4.xml><?xml version="1.0" encoding="utf-8"?>
+<p:notes xmlns:a="http://schemas.openxmlformats.org/drawingml/2006/main" xmlns:r="http://schemas.openxmlformats.org/officeDocument/2006/relationships" xmlns:p="http://schemas.openxmlformats.org/presentationml/2006/main">
+  <p:cSld>
+    <p:spTree>
+      <p:nvGrpSpPr>
+        <p:cNvPr id="1" name=""/>
+        <p:cNvGrpSpPr/>
+        <p:nvPr/>
+      </p:nvGrpSpPr>
+      <p:grpSpPr>
+        <a:xfrm>
+          <a:off x="0" y="0"/>
+          <a:ext cx="0" cy="0"/>
+          <a:chOff x="0" y="0"/>
+          <a:chExt cx="0" cy="0"/>
+        </a:xfrm>
+      </p:grpSpPr>
+      <p:sp>
+        <p:nvSpPr>
+          <p:cNvPr id="2" name="Slide Image Placeholder 1"/>
+          <p:cNvSpPr>
+            <a:spLocks noGrp="1" noRot="1" noChangeAspect="1"/>
+          </p:cNvSpPr>
+          <p:nvPr>
+            <p:ph type="sldImg"/>
+          </p:nvPr>
+        </p:nvSpPr>
+        <p:spPr/>
+      </p:sp>
+      <p:sp>
+        <p:nvSpPr>
+          <p:cNvPr id="3" name="Notes Placeholder 2"/>
+          <p:cNvSpPr>
+            <a:spLocks noGrp="1"/>
+          </p:cNvSpPr>
+          <p:nvPr>
+            <p:ph type="body" idx="1"/>
+          </p:nvPr>
+        </p:nvSpPr>
+        <p:spPr/>
+        <p:txBody>
+          <a:bodyPr/>
+          <a:lstStyle/>
+          <a:p>
+            <a:r>
+              <a:rPr lang="en-US"/>
+              <a:t>SPEAKER</a:t>
+            </a:r>
+          </a:p>
+          <a:p>
+            <a:r>
+              <a:rPr lang="en-US"/>
+              <a:t>One slide, three verbs: Discover, Build, Deploy. Don't tour the portal here - the labs do that. Map each verb to what they will actually do: browse the model catalog, call the model with identity-based auth from Python, publish the agent to a managed runtime.</a:t>
+            </a:r>
+          </a:p>
+          <a:p>
+            <a:r>
+              <a:rPr lang="en-US"/>
+              <a:t>Timing: ~45 seconds.</a:t>
+            </a:r>
+          </a:p>
+          <a:p>
+            <a:r>
+              <a:rPr lang="en-US"/>
+              <a:t>ATTENDEE</a:t>
+            </a:r>
+          </a:p>
+          <a:p>
+            <a:r>
+              <a:rPr lang="en-US"/>
+              <a:t>Foundry is one place to find models and to build, evaluate, and deploy AI apps. In this lab you use all three: a hosted model, a governed Python app, and a hosted agent. Your code authenticates with your identity - no keys in source.</a:t>
+            </a:r>
+          </a:p>
+        </p:txBody>
+      </p:sp>
+      <p:sp>
+        <p:nvSpPr>
+          <p:cNvPr id="4" name="Slide Number Placeholder 3"/>
+          <p:cNvSpPr>
+            <a:spLocks noGrp="1"/>
+          </p:cNvSpPr>
+          <p:nvPr>
+            <p:ph type="sldNum" sz="quarter" idx="5"/>
+          </p:nvPr>
+        </p:nvSpPr>
+        <p:spPr/>
+        <p:txBody>
+          <a:bodyPr/>
+          <a:lstStyle/>
+          <a:p>
+            <a:fld id="{0EAA6A36-79C2-4EC9-93EE-6F62DDC8ACE2}" type="slidenum">
+              <a:rPr lang="en-US" smtClean="0"/>
+              <a:t>4</a:t>
+            </a:fld>
+            <a:endParaRPr lang="en-US"/>
+          </a:p>
+        </p:txBody>
+      </p:sp>
+    </p:spTree>
+    <p:extLst>
+      <p:ext uri="{BB962C8B-B14F-4D97-AF65-F5344CB8AC3E}">
+        <p14:creationId xmlns:p14="http://schemas.microsoft.com/office/powerpoint/2010/main" val="515920316"/>
+      </p:ext>
+    </p:extLst>
+  </p:cSld>
+  <p:clrMapOvr>
+    <a:masterClrMapping/>
+  </p:clrMapOvr>
+</p:notes>
+</file>
+
+<file path=ppt/notesSlides/notesSlide5.xml><?xml version="1.0" encoding="utf-8"?>
+<p:notes xmlns:a="http://schemas.openxmlformats.org/drawingml/2006/main" xmlns:r="http://schemas.openxmlformats.org/officeDocument/2006/relationships" xmlns:p="http://schemas.openxmlformats.org/presentationml/2006/main">
+  <p:cSld>
+    <p:spTree>
+      <p:nvGrpSpPr>
+        <p:cNvPr id="1" name=""/>
+        <p:cNvGrpSpPr/>
+        <p:nvPr/>
+      </p:nvGrpSpPr>
+      <p:grpSpPr>
+        <a:xfrm>
+          <a:off x="0" y="0"/>
+          <a:ext cx="0" cy="0"/>
+          <a:chOff x="0" y="0"/>
+          <a:chExt cx="0" cy="0"/>
+        </a:xfrm>
+      </p:grpSpPr>
+      <p:sp>
+        <p:nvSpPr>
+          <p:cNvPr id="2" name="Slide Image Placeholder 1"/>
+          <p:cNvSpPr>
+            <a:spLocks noGrp="1" noRot="1" noChangeAspect="1"/>
+          </p:cNvSpPr>
+          <p:nvPr>
+            <p:ph type="sldImg"/>
+          </p:nvPr>
+        </p:nvSpPr>
+        <p:spPr/>
+      </p:sp>
+      <p:sp>
+        <p:nvSpPr>
+          <p:cNvPr id="3" name="Notes Placeholder 2"/>
+          <p:cNvSpPr>
+            <a:spLocks noGrp="1"/>
+          </p:cNvSpPr>
+          <p:nvPr>
+            <p:ph type="body" idx="1"/>
+          </p:nvPr>
+        </p:nvSpPr>
+        <p:spPr/>
+        <p:txBody>
+          <a:bodyPr/>
+          <a:lstStyle/>
+          <a:p>
+            <a:r>
+              <a:rPr lang="en-US"/>
+              <a:t>SPEAKER</a:t>
+            </a:r>
+          </a:p>
+          <a:p>
+            <a:r>
+              <a:rPr lang="en-US"/>
+              <a:t>These three terms come back in every lab, so make them stick. The most common confusion is deployment name versus catalog model name - call that out explicitly, because it is the top cause of errors later.</a:t>
+            </a:r>
+          </a:p>
+          <a:p>
+            <a:r>
+              <a:rPr lang="en-US"/>
+              <a:t>Timing: ~45 seconds.</a:t>
+            </a:r>
+          </a:p>
+          <a:p>
+            <a:r>
+              <a:rPr lang="en-US"/>
+              <a:t>ATTENDEE</a:t>
+            </a:r>
+          </a:p>
+          <a:p>
+            <a:r>
+              <a:rPr lang="en-US"/>
+              <a:t>Project = your workspace; it scopes deployments, connections, agents, and access. Model deployment = the callable instance; your code uses the deployment name, not the catalog model name. Hosted agent = your Python workflow running on Foundry's managed runtime behind the Responses API.</a:t>
+            </a:r>
+          </a:p>
+        </p:txBody>
+      </p:sp>
+      <p:sp>
+        <p:nvSpPr>
+          <p:cNvPr id="4" name="Slide Number Placeholder 3"/>
+          <p:cNvSpPr>
+            <a:spLocks noGrp="1"/>
+          </p:cNvSpPr>
+          <p:nvPr>
+            <p:ph type="sldNum" sz="quarter" idx="5"/>
+          </p:nvPr>
+        </p:nvSpPr>
+        <p:spPr/>
+        <p:txBody>
+          <a:bodyPr/>
+          <a:lstStyle/>
+          <a:p>
+            <a:fld id="{0EAA6A36-79C2-4EC9-93EE-6F62DDC8ACE2}" type="slidenum">
+              <a:rPr lang="en-US" smtClean="0"/>
+              <a:t>5</a:t>
+            </a:fld>
+            <a:endParaRPr lang="en-US"/>
+          </a:p>
+        </p:txBody>
+      </p:sp>
+    </p:spTree>
+    <p:extLst>
+      <p:ext uri="{BB962C8B-B14F-4D97-AF65-F5344CB8AC3E}">
+        <p14:creationId xmlns:p14="http://schemas.microsoft.com/office/powerpoint/2010/main" val="1772364913"/>
+      </p:ext>
+    </p:extLst>
+  </p:cSld>
+  <p:clrMapOvr>
+    <a:masterClrMapping/>
+  </p:clrMapOvr>
+</p:notes>
+</file>
+
+<file path=ppt/notesSlides/notesSlide6.xml><?xml version="1.0" encoding="utf-8"?>
+<p:notes xmlns:a="http://schemas.openxmlformats.org/drawingml/2006/main" xmlns:r="http://schemas.openxmlformats.org/officeDocument/2006/relationships" xmlns:p="http://schemas.openxmlformats.org/presentationml/2006/main">
+  <p:cSld>
+    <p:spTree>
+      <p:nvGrpSpPr>
+        <p:cNvPr id="1" name=""/>
+        <p:cNvGrpSpPr/>
+        <p:nvPr/>
+      </p:nvGrpSpPr>
+      <p:grpSpPr>
+        <a:xfrm>
+          <a:off x="0" y="0"/>
+          <a:ext cx="0" cy="0"/>
+          <a:chOff x="0" y="0"/>
+          <a:chExt cx="0" cy="0"/>
+        </a:xfrm>
+      </p:grpSpPr>
+      <p:sp>
+        <p:nvSpPr>
+          <p:cNvPr id="2" name="Slide Image Placeholder 1"/>
+          <p:cNvSpPr>
+            <a:spLocks noGrp="1" noRot="1" noChangeAspect="1"/>
+          </p:cNvSpPr>
+          <p:nvPr>
+            <p:ph type="sldImg"/>
+          </p:nvPr>
+        </p:nvSpPr>
+        <p:spPr/>
+      </p:sp>
+      <p:sp>
+        <p:nvSpPr>
+          <p:cNvPr id="3" name="Notes Placeholder 2"/>
+          <p:cNvSpPr>
+            <a:spLocks noGrp="1"/>
+          </p:cNvSpPr>
+          <p:nvPr>
+            <p:ph type="body" idx="1"/>
+          </p:nvPr>
+        </p:nvSpPr>
+        <p:spPr/>
+        <p:txBody>
+          <a:bodyPr/>
+          <a:lstStyle/>
+          <a:p>
+            <a:r>
+              <a:rPr lang="en-US"/>
+              <a:t>SPEAKER</a:t>
+            </a:r>
+          </a:p>
+          <a:p>
+            <a:r>
+              <a:rPr lang="en-US"/>
+              <a:t>Walk the five steps quickly so people know where they are at any moment. Tell them you will call out each step by number during the session. Note Lab 5 (model comparison) is a self-paced extension - nobody should feel behind if they don't reach it live.</a:t>
+            </a:r>
+          </a:p>
+          <a:p>
+            <a:r>
+              <a:rPr lang="en-US"/>
+              <a:t>Timing: ~30 seconds.</a:t>
+            </a:r>
+          </a:p>
+          <a:p>
+            <a:r>
+              <a:rPr lang="en-US"/>
+              <a:t>ATTENDEE</a:t>
+            </a:r>
+          </a:p>
+          <a:p>
+            <a:r>
+              <a:rPr lang="en-US"/>
+              <a:t>Five steps: 1 Discover a model in the catalog, 2 Verify your project and .env, 3 Connect via the Responses API, 4 Govern with structured JSON and routing rules, 5 Deploy a hosted agent. Lab 5 is optional and self-paced.</a:t>
+            </a:r>
+          </a:p>
+        </p:txBody>
+      </p:sp>
+      <p:sp>
+        <p:nvSpPr>
+          <p:cNvPr id="4" name="Slide Number Placeholder 3"/>
+          <p:cNvSpPr>
+            <a:spLocks noGrp="1"/>
+          </p:cNvSpPr>
+          <p:nvPr>
+            <p:ph type="sldNum" sz="quarter" idx="5"/>
+          </p:nvPr>
+        </p:nvSpPr>
+        <p:spPr/>
+        <p:txBody>
+          <a:bodyPr/>
+          <a:lstStyle/>
+          <a:p>
+            <a:fld id="{0EAA6A36-79C2-4EC9-93EE-6F62DDC8ACE2}" type="slidenum">
+              <a:rPr lang="en-US" smtClean="0"/>
+              <a:t>6</a:t>
+            </a:fld>
+            <a:endParaRPr lang="en-US"/>
+          </a:p>
+        </p:txBody>
+      </p:sp>
+    </p:spTree>
+    <p:extLst>
+      <p:ext uri="{BB962C8B-B14F-4D97-AF65-F5344CB8AC3E}">
+        <p14:creationId xmlns:p14="http://schemas.microsoft.com/office/powerpoint/2010/main" val="2320804653"/>
+      </p:ext>
+    </p:extLst>
+  </p:cSld>
+  <p:clrMapOvr>
+    <a:masterClrMapping/>
+  </p:clrMapOvr>
+</p:notes>
+</file>
+
+<file path=ppt/notesSlides/notesSlide7.xml><?xml version="1.0" encoding="utf-8"?>
+<p:notes xmlns:a="http://schemas.openxmlformats.org/drawingml/2006/main" xmlns:r="http://schemas.openxmlformats.org/officeDocument/2006/relationships" xmlns:p="http://schemas.openxmlformats.org/presentationml/2006/main">
+  <p:cSld>
+    <p:spTree>
+      <p:nvGrpSpPr>
+        <p:cNvPr id="1" name=""/>
+        <p:cNvGrpSpPr/>
+        <p:nvPr/>
+      </p:nvGrpSpPr>
+      <p:grpSpPr>
+        <a:xfrm>
+          <a:off x="0" y="0"/>
+          <a:ext cx="0" cy="0"/>
+          <a:chOff x="0" y="0"/>
+          <a:chExt cx="0" cy="0"/>
+        </a:xfrm>
+      </p:grpSpPr>
+      <p:sp>
+        <p:nvSpPr>
+          <p:cNvPr id="2" name="Slide Image Placeholder 1"/>
+          <p:cNvSpPr>
+            <a:spLocks noGrp="1" noRot="1" noChangeAspect="1"/>
+          </p:cNvSpPr>
+          <p:nvPr>
+            <p:ph type="sldImg"/>
+          </p:nvPr>
+        </p:nvSpPr>
+        <p:spPr/>
+      </p:sp>
+      <p:sp>
+        <p:nvSpPr>
+          <p:cNvPr id="3" name="Notes Placeholder 2"/>
+          <p:cNvSpPr>
+            <a:spLocks noGrp="1"/>
+          </p:cNvSpPr>
+          <p:nvPr>
+            <p:ph type="body" idx="1"/>
+          </p:nvPr>
+        </p:nvSpPr>
+        <p:spPr/>
+        <p:txBody>
+          <a:bodyPr/>
+          <a:lstStyle/>
+          <a:p>
+            <a:r>
+              <a:rPr lang="en-US"/>
+              <a:t>SPEAKER</a:t>
+            </a:r>
+          </a:p>
+          <a:p>
+            <a:r>
+              <a:rPr lang="en-US"/>
+              <a:t>This is the slide that prevents most support requests. Everything is pre-provisioned: VM, Azure credentials, configured .env with the project endpoint, gpt-5.4-mini deployed, VS Code with the Foundry Toolkit.</a:t>
+            </a:r>
+          </a:p>
+          <a:p>
+            <a:r>
+              <a:rPr lang="en-US"/>
+              <a:t>Demonstrate the keyboard / Type action in Skillable - typing credentials by hand is the number one cause of sign-in failures. Ask everyone to open the workspace folder and click Trust now.</a:t>
+            </a:r>
+          </a:p>
+          <a:p>
+            <a:r>
+              <a:rPr lang="en-US"/>
+              <a:t>Timing: ~60 seconds. Pause here until hands are down.</a:t>
+            </a:r>
+          </a:p>
+          <a:p>
+            <a:r>
+              <a:rPr lang="en-US"/>
+              <a:t>ATTENDEE</a:t>
+            </a:r>
+          </a:p>
+          <a:p>
+            <a:r>
+              <a:rPr lang="en-US"/>
+              <a:t>Start here: open C:\Users\LabUser\Desktop\AI-Tour-ILL335-main in VS Code and trust the workspace, then follow the Skillable instructions. Use the keyboard icon / Type action to enter supplied credentials instead of typing them. Your .env is already configured and gpt-5.4-mini is already deployed - don't recreate them.</a:t>
+            </a:r>
+          </a:p>
+        </p:txBody>
+      </p:sp>
+      <p:sp>
+        <p:nvSpPr>
+          <p:cNvPr id="4" name="Slide Number Placeholder 3"/>
+          <p:cNvSpPr>
+            <a:spLocks noGrp="1"/>
+          </p:cNvSpPr>
+          <p:nvPr>
+            <p:ph type="sldNum" sz="quarter" idx="5"/>
+          </p:nvPr>
+        </p:nvSpPr>
+        <p:spPr/>
+        <p:txBody>
+          <a:bodyPr/>
+          <a:lstStyle/>
+          <a:p>
+            <a:fld id="{0EAA6A36-79C2-4EC9-93EE-6F62DDC8ACE2}" type="slidenum">
+              <a:rPr lang="en-US" smtClean="0"/>
+              <a:t>7</a:t>
+            </a:fld>
+            <a:endParaRPr lang="en-US"/>
+          </a:p>
+        </p:txBody>
+      </p:sp>
+    </p:spTree>
+    <p:extLst>
+      <p:ext uri="{BB962C8B-B14F-4D97-AF65-F5344CB8AC3E}">
+        <p14:creationId xmlns:p14="http://schemas.microsoft.com/office/powerpoint/2010/main" val="3368095484"/>
+      </p:ext>
+    </p:extLst>
+  </p:cSld>
+  <p:clrMapOvr>
+    <a:masterClrMapping/>
+  </p:clrMapOvr>
+</p:notes>
+</file>
+
+<file path=ppt/notesSlides/notesSlide8.xml><?xml version="1.0" encoding="utf-8"?>
+<p:notes xmlns:a="http://schemas.openxmlformats.org/drawingml/2006/main" xmlns:r="http://schemas.openxmlformats.org/officeDocument/2006/relationships" xmlns:p="http://schemas.openxmlformats.org/presentationml/2006/main">
+  <p:cSld>
+    <p:spTree>
+      <p:nvGrpSpPr>
+        <p:cNvPr id="1" name=""/>
+        <p:cNvGrpSpPr/>
+        <p:nvPr/>
+      </p:nvGrpSpPr>
+      <p:grpSpPr>
+        <a:xfrm>
+          <a:off x="0" y="0"/>
+          <a:ext cx="0" cy="0"/>
+          <a:chOff x="0" y="0"/>
+          <a:chExt cx="0" cy="0"/>
+        </a:xfrm>
+      </p:grpSpPr>
+      <p:sp>
+        <p:nvSpPr>
+          <p:cNvPr id="2" name="Slide Image Placeholder 1"/>
+          <p:cNvSpPr>
+            <a:spLocks noGrp="1" noRot="1" noChangeAspect="1"/>
+          </p:cNvSpPr>
+          <p:nvPr>
+            <p:ph type="sldImg"/>
+          </p:nvPr>
+        </p:nvSpPr>
+        <p:spPr/>
+      </p:sp>
+      <p:sp>
+        <p:nvSpPr>
+          <p:cNvPr id="3" name="Notes Placeholder 2"/>
+          <p:cNvSpPr>
+            <a:spLocks noGrp="1"/>
+          </p:cNvSpPr>
+          <p:nvPr>
+            <p:ph type="body" idx="1"/>
+          </p:nvPr>
+        </p:nvSpPr>
+        <p:spPr/>
+        <p:txBody>
+          <a:bodyPr/>
+          <a:lstStyle/>
+          <a:p>
+            <a:r>
+              <a:rPr lang="en-US"/>
+              <a:t>SPEAKER</a:t>
+            </a:r>
+          </a:p>
+          <a:p>
+            <a:r>
+              <a:rPr lang="en-US"/>
+              <a:t>Show the shape of the pipeline before they build it, so the code makes sense. Land the final line hard: the model identifies signals, but your code makes the routing decision. That is the responsible-AI spine of the whole lab.</a:t>
+            </a:r>
+          </a:p>
+          <a:p>
+            <a:r>
+              <a:rPr lang="en-US"/>
+              <a:t>Timing: ~45 seconds.</a:t>
+            </a:r>
+          </a:p>
+          <a:p>
+            <a:r>
+              <a:rPr lang="en-US"/>
+              <a:t>ATTENDEE</a:t>
+            </a:r>
+          </a:p>
+          <a:p>
+            <a:r>
+              <a:rPr lang="en-US"/>
+              <a:t>What you build: consumer feedback in, a prompt with instructions and input, a call to gpt-5.4-mini, a structured JSON result, then a routing decision to human review or a dashboard. Deterministic code - not the model - decides where an item goes.</a:t>
+            </a:r>
+          </a:p>
+        </p:txBody>
+      </p:sp>
+      <p:sp>
+        <p:nvSpPr>
+          <p:cNvPr id="4" name="Slide Number Placeholder 3"/>
+          <p:cNvSpPr>
+            <a:spLocks noGrp="1"/>
+          </p:cNvSpPr>
+          <p:nvPr>
+            <p:ph type="sldNum" sz="quarter" idx="5"/>
+          </p:nvPr>
+        </p:nvSpPr>
+        <p:spPr/>
+        <p:txBody>
+          <a:bodyPr/>
+          <a:lstStyle/>
+          <a:p>
+            <a:fld id="{0EAA6A36-79C2-4EC9-93EE-6F62DDC8ACE2}" type="slidenum">
+              <a:rPr lang="en-US" smtClean="0"/>
+              <a:t>8</a:t>
+            </a:fld>
+            <a:endParaRPr lang="en-US"/>
+          </a:p>
+        </p:txBody>
+      </p:sp>
+    </p:spTree>
+    <p:extLst>
+      <p:ext uri="{BB962C8B-B14F-4D97-AF65-F5344CB8AC3E}">
+        <p14:creationId xmlns:p14="http://schemas.microsoft.com/office/powerpoint/2010/main" val="296136549"/>
+      </p:ext>
+    </p:extLst>
+  </p:cSld>
+  <p:clrMapOvr>
+    <a:masterClrMapping/>
+  </p:clrMapOvr>
+</p:notes>
+</file>
+
+<file path=ppt/notesSlides/notesSlide9.xml><?xml version="1.0" encoding="utf-8"?>
+<p:notes xmlns:a="http://schemas.openxmlformats.org/drawingml/2006/main" xmlns:r="http://schemas.openxmlformats.org/officeDocument/2006/relationships" xmlns:p="http://schemas.openxmlformats.org/presentationml/2006/main">
+  <p:cSld>
+    <p:spTree>
+      <p:nvGrpSpPr>
+        <p:cNvPr id="1" name=""/>
+        <p:cNvGrpSpPr/>
+        <p:nvPr/>
+      </p:nvGrpSpPr>
+      <p:grpSpPr>
+        <a:xfrm>
+          <a:off x="0" y="0"/>
+          <a:ext cx="0" cy="0"/>
+          <a:chOff x="0" y="0"/>
+          <a:chExt cx="0" cy="0"/>
+        </a:xfrm>
+      </p:grpSpPr>
+      <p:sp>
+        <p:nvSpPr>
+          <p:cNvPr id="2" name="Slide Image Placeholder 1"/>
+          <p:cNvSpPr>
+            <a:spLocks noGrp="1" noRot="1" noChangeAspect="1"/>
+          </p:cNvSpPr>
+          <p:nvPr>
+            <p:ph type="sldImg"/>
+          </p:nvPr>
+        </p:nvSpPr>
+        <p:spPr/>
+      </p:sp>
+      <p:sp>
+        <p:nvSpPr>
+          <p:cNvPr id="3" name="Notes Placeholder 2"/>
+          <p:cNvSpPr>
+            <a:spLocks noGrp="1"/>
+          </p:cNvSpPr>
+          <p:nvPr>
+            <p:ph type="body" idx="1"/>
+          </p:nvPr>
+        </p:nvSpPr>
+        <p:spPr/>
+        <p:txBody>
+          <a:bodyPr/>
+          <a:lstStyle/>
+          <a:p>
+            <a:r>
+              <a:rPr lang="en-US"/>
+              <a:t>SPEAKER</a:t>
+            </a:r>
+          </a:p>
+          <a:p>
+            <a:r>
+              <a:rPr lang="en-US"/>
+              <a:t>Set the working rhythm. Ask attendees to keep Skillable and VS Code side by side. Name the five checkpoints out loud: validator PASS, inference output, valid JSON, local agent response, hosted status active - you will pause at each.</a:t>
+            </a:r>
+          </a:p>
+          <a:p>
+            <a:r>
+              <a:rPr lang="en-US"/>
+              <a:t>Ask proctors to stand and be visible. Reinforce the security rule: no passwords, tokens, or .env values in chat or code.</a:t>
+            </a:r>
+          </a:p>
+          <a:p>
+            <a:r>
+              <a:rPr lang="en-US"/>
+              <a:t>Timing: ~60 seconds.</a:t>
+            </a:r>
+          </a:p>
+          <a:p>
+            <a:r>
+              <a:rPr lang="en-US"/>
+              <a:t>ATTENDEE</a:t>
+            </a:r>
+          </a:p>
+          <a:p>
+            <a:r>
+              <a:rPr lang="en-US"/>
+              <a:t>Follow along and stop at each checkpoint. If your screen differs from the instructor's, raise your hand immediately - share the error text only, never credentials. Never paste passwords, tokens, or .env values into chat or source code.</a:t>
+            </a:r>
+          </a:p>
+        </p:txBody>
+      </p:sp>
+      <p:sp>
+        <p:nvSpPr>
+          <p:cNvPr id="4" name="Slide Number Placeholder 3"/>
+          <p:cNvSpPr>
+            <a:spLocks noGrp="1"/>
+          </p:cNvSpPr>
+          <p:nvPr>
+            <p:ph type="sldNum" sz="quarter" idx="5"/>
+          </p:nvPr>
+        </p:nvSpPr>
+        <p:spPr/>
+        <p:txBody>
+          <a:bodyPr/>
+          <a:lstStyle/>
+          <a:p>
+            <a:fld id="{0EAA6A36-79C2-4EC9-93EE-6F62DDC8ACE2}" type="slidenum">
+              <a:rPr lang="en-US" smtClean="0"/>
+              <a:t>9</a:t>
+            </a:fld>
+            <a:endParaRPr lang="en-US"/>
+          </a:p>
+        </p:txBody>
+      </p:sp>
+    </p:spTree>
+    <p:extLst>
+      <p:ext uri="{BB962C8B-B14F-4D97-AF65-F5344CB8AC3E}">
+        <p14:creationId xmlns:p14="http://schemas.microsoft.com/office/powerpoint/2010/main" val="2265548070"/>
       </p:ext>
     </p:extLst>
   </p:cSld>
@@ -16804,7 +16744,7 @@
                 </a:gradFill>
                 <a:latin typeface="+mj-lt"/>
                 <a:cs typeface="Segoe Sans Display Semibold" pitchFamily="2" charset="0"/>
-                <a:hlinkClick r:id="rId2">
+                <a:hlinkClick r:id="rId3">
                   <a:extLst>
                     <a:ext uri="{A12FA001-AC4F-418D-AE19-62706E023703}">
                       <ahyp:hlinkClr xmlns:ahyp="http://schemas.microsoft.com/office/drawing/2018/hyperlinkcolor" val="tx"/>
@@ -17101,7 +17041,7 @@
                 </a:gradFill>
                 <a:latin typeface="+mj-lt"/>
                 <a:cs typeface="Segoe Sans Display Semibold" pitchFamily="2" charset="0"/>
-                <a:hlinkClick r:id="rId3">
+                <a:hlinkClick r:id="rId4">
                   <a:extLst>
                     <a:ext uri="{A12FA001-AC4F-418D-AE19-62706E023703}">
                       <ahyp:hlinkClr xmlns:ahyp="http://schemas.microsoft.com/office/drawing/2018/hyperlinkcolor" val="tx"/>
@@ -19839,7 +19779,7 @@
             <a:blip>
               <a:extLst>
                 <a:ext uri="{96DAC541-7B7A-43D3-8B79-37D633B846F1}">
-                  <asvg:svgBlip xmlns:asvg="http://schemas.microsoft.com/office/drawing/2016/SVG/main" r:embed="rId2"/>
+                  <asvg:svgBlip xmlns:asvg="http://schemas.microsoft.com/office/drawing/2016/SVG/main" r:embed="rId3"/>
                 </a:ext>
               </a:extLst>
             </a:blip>
@@ -20180,7 +20120,7 @@
             <a:blip>
               <a:extLst>
                 <a:ext uri="{96DAC541-7B7A-43D3-8B79-37D633B846F1}">
-                  <asvg:svgBlip xmlns:asvg="http://schemas.microsoft.com/office/drawing/2016/SVG/main" r:embed="rId3"/>
+                  <asvg:svgBlip xmlns:asvg="http://schemas.microsoft.com/office/drawing/2016/SVG/main" r:embed="rId4"/>
                 </a:ext>
               </a:extLst>
             </a:blip>
@@ -20948,7 +20888,7 @@
             <a:blip>
               <a:extLst>
                 <a:ext uri="{96DAC541-7B7A-43D3-8B79-37D633B846F1}">
-                  <asvg:svgBlip xmlns:asvg="http://schemas.microsoft.com/office/drawing/2016/SVG/main" r:embed="rId4"/>
+                  <asvg:svgBlip xmlns:asvg="http://schemas.microsoft.com/office/drawing/2016/SVG/main" r:embed="rId5"/>
                 </a:ext>
               </a:extLst>
             </a:blip>
@@ -21721,7 +21661,7 @@
           <a:blip>
             <a:extLst>
               <a:ext uri="{96DAC541-7B7A-43D3-8B79-37D633B846F1}">
-                <asvg:svgBlip xmlns:asvg="http://schemas.microsoft.com/office/drawing/2016/SVG/main" r:embed="rId2"/>
+                <asvg:svgBlip xmlns:asvg="http://schemas.microsoft.com/office/drawing/2016/SVG/main" r:embed="rId3"/>
               </a:ext>
             </a:extLst>
           </a:blip>
@@ -21843,7 +21783,7 @@
           <a:blip>
             <a:extLst>
               <a:ext uri="{96DAC541-7B7A-43D3-8B79-37D633B846F1}">
-                <asvg:svgBlip xmlns:asvg="http://schemas.microsoft.com/office/drawing/2016/SVG/main" r:embed="rId3"/>
+                <asvg:svgBlip xmlns:asvg="http://schemas.microsoft.com/office/drawing/2016/SVG/main" r:embed="rId4"/>
               </a:ext>
             </a:extLst>
           </a:blip>
@@ -21965,7 +21905,7 @@
           <a:blip>
             <a:extLst>
               <a:ext uri="{96DAC541-7B7A-43D3-8B79-37D633B846F1}">
-                <asvg:svgBlip xmlns:asvg="http://schemas.microsoft.com/office/drawing/2016/SVG/main" r:embed="rId4"/>
+                <asvg:svgBlip xmlns:asvg="http://schemas.microsoft.com/office/drawing/2016/SVG/main" r:embed="rId5"/>
               </a:ext>
             </a:extLst>
           </a:blip>
@@ -31013,7 +30953,7 @@
           <a:blip>
             <a:extLst>
               <a:ext uri="{96DAC541-7B7A-43D3-8B79-37D633B846F1}">
-                <asvg:svgBlip xmlns:asvg="http://schemas.microsoft.com/office/drawing/2016/SVG/main" r:embed="rId2"/>
+                <asvg:svgBlip xmlns:asvg="http://schemas.microsoft.com/office/drawing/2016/SVG/main" r:embed="rId3"/>
               </a:ext>
             </a:extLst>
           </a:blip>
@@ -31052,7 +30992,7 @@
           <a:blip>
             <a:extLst>
               <a:ext uri="{96DAC541-7B7A-43D3-8B79-37D633B846F1}">
-                <asvg:svgBlip xmlns:asvg="http://schemas.microsoft.com/office/drawing/2016/SVG/main" r:embed="rId3"/>
+                <asvg:svgBlip xmlns:asvg="http://schemas.microsoft.com/office/drawing/2016/SVG/main" r:embed="rId4"/>
               </a:ext>
             </a:extLst>
           </a:blip>
@@ -31091,7 +31031,7 @@
           <a:blip>
             <a:extLst>
               <a:ext uri="{96DAC541-7B7A-43D3-8B79-37D633B846F1}">
-                <asvg:svgBlip xmlns:asvg="http://schemas.microsoft.com/office/drawing/2016/SVG/main" r:embed="rId4"/>
+                <asvg:svgBlip xmlns:asvg="http://schemas.microsoft.com/office/drawing/2016/SVG/main" r:embed="rId5"/>
               </a:ext>
             </a:extLst>
           </a:blip>
@@ -32377,31 +32317,6 @@
 </file>
 
 <file path=customXml/item1.xml><?xml version="1.0" encoding="utf-8"?>
-<p:properties xmlns:p="http://schemas.microsoft.com/office/2006/metadata/properties" xmlns:xsi="http://www.w3.org/2001/XMLSchema-instance" xmlns:pc="http://schemas.microsoft.com/office/infopath/2007/PartnerControls">
-  <documentManagement>
-    <_ip_UnifiedCompliancePolicyUIAction xmlns="http://schemas.microsoft.com/sharepoint/v3" xsi:nil="true"/>
-    <_ip_UnifiedCompliancePolicyProperties xmlns="http://schemas.microsoft.com/sharepoint/v3" xsi:nil="true"/>
-    <lcf76f155ced4ddcb4097134ff3c332f xmlns="804751ba-60e0-4191-9865-d7e5284c1d69">
-      <Terms xmlns="http://schemas.microsoft.com/office/infopath/2007/PartnerControls"/>
-    </lcf76f155ced4ddcb4097134ff3c332f>
-    <Number xmlns="804751ba-60e0-4191-9865-d7e5284c1d69" xsi:nil="true"/>
-    <TaxCatchAll xmlns="230e9df3-be65-4c73-a93b-d1236ebd677e" xsi:nil="true"/>
-    <Time xmlns="804751ba-60e0-4191-9865-d7e5284c1d69" xsi:nil="true"/>
-    <content xmlns="804751ba-60e0-4191-9865-d7e5284c1d69" xsi:nil="true"/>
-  </documentManagement>
-</p:properties>
-</file>
-
-<file path=customXml/item2.xml><?xml version="1.0" encoding="utf-8"?>
-<?mso-contentType ?>
-<FormTemplates xmlns="http://schemas.microsoft.com/sharepoint/v3/contenttype/forms">
-  <Display>DocumentLibraryForm</Display>
-  <Edit>DocumentLibraryForm</Edit>
-  <New>DocumentLibraryForm</New>
-</FormTemplates>
-</file>
-
-<file path=customXml/item3.xml><?xml version="1.0" encoding="utf-8"?>
 <ct:contentTypeSchema xmlns:ct="http://schemas.microsoft.com/office/2006/metadata/contentType" xmlns:ma="http://schemas.microsoft.com/office/2006/metadata/properties/metaAttributes" ct:_="" ma:_="" ma:contentTypeName="Document" ma:contentTypeID="0x0101002FE71A6B924FC94981CCAD1A585590D8" ma:contentTypeVersion="27" ma:contentTypeDescription="Create a new document." ma:contentTypeScope="" ma:versionID="566528f2922ad54e26a908d2133454c1">
   <xsd:schema xmlns:xsd="http://www.w3.org/2001/XMLSchema" xmlns:xs="http://www.w3.org/2001/XMLSchema" xmlns:p="http://schemas.microsoft.com/office/2006/metadata/properties" xmlns:ns1="http://schemas.microsoft.com/sharepoint/v3" xmlns:ns2="804751ba-60e0-4191-9865-d7e5284c1d69" xmlns:ns3="913b567d-4c83-4181-a45c-f04ce7e1b72e" xmlns:ns4="230e9df3-be65-4c73-a93b-d1236ebd677e" targetNamespace="http://schemas.microsoft.com/office/2006/metadata/properties" ma:root="true" ma:fieldsID="6c91453d1ce2972ce38a1123b4b20cb5" ns1:_="" ns2:_="" ns3:_="" ns4:_="">
     <xsd:import namespace="http://schemas.microsoft.com/sharepoint/v3"/>
@@ -32708,34 +32623,32 @@
 </ct:contentTypeSchema>
 </file>
 
-<file path=customXml/itemProps1.xml><?xml version="1.0" encoding="utf-8"?>
-<ds:datastoreItem xmlns:ds="http://schemas.openxmlformats.org/officeDocument/2006/customXml" ds:itemID="{21BBFC1A-40E2-4190-9ED0-DD22B043F5E9}">
-  <ds:schemaRefs>
-    <ds:schemaRef ds:uri="http://purl.org/dc/elements/1.1/"/>
-    <ds:schemaRef ds:uri="http://schemas.microsoft.com/office/2006/documentManagement/types"/>
-    <ds:schemaRef ds:uri="http://schemas.microsoft.com/sharepoint/v3"/>
-    <ds:schemaRef ds:uri="http://www.w3.org/XML/1998/namespace"/>
-    <ds:schemaRef ds:uri="230e9df3-be65-4c73-a93b-d1236ebd677e"/>
-    <ds:schemaRef ds:uri="913b567d-4c83-4181-a45c-f04ce7e1b72e"/>
-    <ds:schemaRef ds:uri="http://purl.org/dc/dcmitype/"/>
-    <ds:schemaRef ds:uri="http://schemas.microsoft.com/office/infopath/2007/PartnerControls"/>
-    <ds:schemaRef ds:uri="http://schemas.openxmlformats.org/package/2006/metadata/core-properties"/>
-    <ds:schemaRef ds:uri="804751ba-60e0-4191-9865-d7e5284c1d69"/>
-    <ds:schemaRef ds:uri="http://schemas.microsoft.com/office/2006/metadata/properties"/>
-    <ds:schemaRef ds:uri="http://purl.org/dc/terms/"/>
-  </ds:schemaRefs>
-</ds:datastoreItem>
+<file path=customXml/item2.xml><?xml version="1.0" encoding="utf-8"?>
+<?mso-contentType ?>
+<FormTemplates xmlns="http://schemas.microsoft.com/sharepoint/v3/contenttype/forms">
+  <Display>DocumentLibraryForm</Display>
+  <Edit>DocumentLibraryForm</Edit>
+  <New>DocumentLibraryForm</New>
+</FormTemplates>
 </file>
 
-<file path=customXml/itemProps2.xml><?xml version="1.0" encoding="utf-8"?>
-<ds:datastoreItem xmlns:ds="http://schemas.openxmlformats.org/officeDocument/2006/customXml" ds:itemID="{911D3613-E70D-41EC-A205-2FA057EAAF25}">
-  <ds:schemaRefs>
-    <ds:schemaRef ds:uri="http://schemas.microsoft.com/sharepoint/v3/contenttype/forms"/>
-  </ds:schemaRefs>
-</ds:datastoreItem>
+<file path=customXml/item3.xml><?xml version="1.0" encoding="utf-8"?>
+<p:properties xmlns:p="http://schemas.microsoft.com/office/2006/metadata/properties" xmlns:xsi="http://www.w3.org/2001/XMLSchema-instance" xmlns:pc="http://schemas.microsoft.com/office/infopath/2007/PartnerControls">
+  <documentManagement>
+    <_ip_UnifiedCompliancePolicyUIAction xmlns="http://schemas.microsoft.com/sharepoint/v3" xsi:nil="true"/>
+    <_ip_UnifiedCompliancePolicyProperties xmlns="http://schemas.microsoft.com/sharepoint/v3" xsi:nil="true"/>
+    <lcf76f155ced4ddcb4097134ff3c332f xmlns="804751ba-60e0-4191-9865-d7e5284c1d69">
+      <Terms xmlns="http://schemas.microsoft.com/office/infopath/2007/PartnerControls"/>
+    </lcf76f155ced4ddcb4097134ff3c332f>
+    <Number xmlns="804751ba-60e0-4191-9865-d7e5284c1d69" xsi:nil="true"/>
+    <TaxCatchAll xmlns="230e9df3-be65-4c73-a93b-d1236ebd677e" xsi:nil="true"/>
+    <Time xmlns="804751ba-60e0-4191-9865-d7e5284c1d69" xsi:nil="true"/>
+    <content xmlns="804751ba-60e0-4191-9865-d7e5284c1d69" xsi:nil="true"/>
+  </documentManagement>
+</p:properties>
 </file>
 
-<file path=customXml/itemProps3.xml><?xml version="1.0" encoding="utf-8"?>
+<file path=customXml/itemProps1.xml><?xml version="1.0" encoding="utf-8"?>
 <ds:datastoreItem xmlns:ds="http://schemas.openxmlformats.org/officeDocument/2006/customXml" ds:itemID="{CBAB5C69-0FF7-452F-B9FB-A7F940C3BA46}">
   <ds:schemaRefs>
     <ds:schemaRef ds:uri="230e9df3-be65-4c73-a93b-d1236ebd677e"/>
@@ -32756,8 +32669,35 @@
 </ds:datastoreItem>
 </file>
 
+<file path=customXml/itemProps2.xml><?xml version="1.0" encoding="utf-8"?>
+<ds:datastoreItem xmlns:ds="http://schemas.openxmlformats.org/officeDocument/2006/customXml" ds:itemID="{911D3613-E70D-41EC-A205-2FA057EAAF25}">
+  <ds:schemaRefs>
+    <ds:schemaRef ds:uri="http://schemas.microsoft.com/sharepoint/v3/contenttype/forms"/>
+  </ds:schemaRefs>
+</ds:datastoreItem>
+</file>
+
+<file path=customXml/itemProps3.xml><?xml version="1.0" encoding="utf-8"?>
+<ds:datastoreItem xmlns:ds="http://schemas.openxmlformats.org/officeDocument/2006/customXml" ds:itemID="{21BBFC1A-40E2-4190-9ED0-DD22B043F5E9}">
+  <ds:schemaRefs>
+    <ds:schemaRef ds:uri="http://purl.org/dc/elements/1.1/"/>
+    <ds:schemaRef ds:uri="http://schemas.microsoft.com/office/2006/documentManagement/types"/>
+    <ds:schemaRef ds:uri="http://schemas.microsoft.com/sharepoint/v3"/>
+    <ds:schemaRef ds:uri="http://www.w3.org/XML/1998/namespace"/>
+    <ds:schemaRef ds:uri="230e9df3-be65-4c73-a93b-d1236ebd677e"/>
+    <ds:schemaRef ds:uri="913b567d-4c83-4181-a45c-f04ce7e1b72e"/>
+    <ds:schemaRef ds:uri="http://purl.org/dc/dcmitype/"/>
+    <ds:schemaRef ds:uri="http://schemas.microsoft.com/office/infopath/2007/PartnerControls"/>
+    <ds:schemaRef ds:uri="http://schemas.openxmlformats.org/package/2006/metadata/core-properties"/>
+    <ds:schemaRef ds:uri="804751ba-60e0-4191-9865-d7e5284c1d69"/>
+    <ds:schemaRef ds:uri="http://schemas.microsoft.com/office/2006/metadata/properties"/>
+    <ds:schemaRef ds:uri="http://purl.org/dc/terms/"/>
+  </ds:schemaRefs>
+</ds:datastoreItem>
+</file>
+
 <file path=docMetadata/LabelInfo.xml><?xml version="1.0" encoding="utf-8"?>
 <clbl:labelList xmlns:clbl="http://schemas.microsoft.com/office/2020/mipLabelMetadata">
-  <clbl:label id="{1a19d03a-48bc-4359-8038-5b5f6d5847c3}" enabled="1" method="Standard" siteId="{72f988bf-86f1-41af-91ab-2d7cd011db47}" removed="0"/>
+  <clbl:label id="{87867195-f2b8-4ac2-b0b6-6bb73cb33afc}" enabled="1" method="Privileged" siteId="{72f988bf-86f1-41af-91ab-2d7cd011db47}" removed="0"/>
 </clbl:labelList>
 </file>
</xml_diff>